<commit_message>
Add Our Solution + Advantages slide (6-benefit grid) ahead of the differentiator slide
</commit_message>
<xml_diff>
--- a/Health_First_Week6_Pitch.pptx
+++ b/Health_First_Week6_Pitch.pptx
@@ -13,6 +13,7 @@
     <p:sldId id="261" r:id="rId13"/>
     <p:sldId id="262" r:id="rId14"/>
     <p:sldId id="263" r:id="rId15"/>
+    <p:sldId id="264" r:id="rId16"/>
   </p:sldIdLst>
   <p:sldSz cx="12191695" cy="6858000" type="screen4x3"/>
   <p:notesSz cx="6858000" cy="9144000"/>
@@ -649,7 +650,7 @@
           <a:lstStyle/>
           <a:p>
             <a:r>
-              <a:t>This slide is the differentiator judges will remember. Restrict vs Reward.</a:t>
+              <a:t>State the solution in one line, then hit the six advantages quickly - this sets up the comparison slide next.</a:t>
             </a:r>
           </a:p>
         </p:txBody>
@@ -719,7 +720,7 @@
           <a:lstStyle/>
           <a:p>
             <a:r>
-              <a:t>Walk the flow left to right, then flag the sleep-timing fix as proof of real engineering rigor.</a:t>
+              <a:t>This slide is the differentiator judges will remember. Restrict vs Reward.</a:t>
             </a:r>
           </a:p>
         </p:txBody>
@@ -789,7 +790,7 @@
           <a:lstStyle/>
           <a:p>
             <a:r>
-              <a:t>Keep this brief - one breath explaining the diagram, then move to Wider Impact.</a:t>
+              <a:t>Walk the flow left to right, then flag the sleep-timing fix as proof of real engineering rigor.</a:t>
             </a:r>
           </a:p>
         </p:txBody>
@@ -859,7 +860,7 @@
           <a:lstStyle/>
           <a:p>
             <a:r>
-              <a:t>This is the slide that answers 'so what' for judges - why this matters beyond one demo family.</a:t>
+              <a:t>Keep this brief - one breath explaining the diagram, then move to Wider Impact.</a:t>
             </a:r>
           </a:p>
         </p:txBody>
@@ -929,7 +930,7 @@
           <a:lstStyle/>
           <a:p>
             <a:r>
-              <a:t>Say the proof bullets, then read the links out loud slowly if this is on screen during the recorded pitch.</a:t>
+              <a:t>This is the slide that answers 'so what' for judges - why this matters beyond one demo family.</a:t>
             </a:r>
           </a:p>
         </p:txBody>
@@ -955,6 +956,76 @@
 </file>
 
 <file path=ppt/notesSlides/notesSlide8.xml><?xml version="1.0" encoding="utf-8"?>
+<p:notes xmlns:a="http://schemas.openxmlformats.org/drawingml/2006/main" xmlns:p="http://schemas.openxmlformats.org/presentationml/2006/main" xmlns:r="http://schemas.openxmlformats.org/officeDocument/2006/relationships">
+  <p:cSld>
+    <p:spTree>
+      <p:nvGrpSpPr>
+        <p:cNvPr id="1" name=""/>
+        <p:cNvGrpSpPr/>
+        <p:nvPr/>
+      </p:nvGrpSpPr>
+      <p:grpSpPr>
+        <a:xfrm>
+          <a:off x="0" y="0"/>
+          <a:ext cx="0" cy="0"/>
+          <a:chOff x="0" y="0"/>
+          <a:chExt cx="0" cy="0"/>
+        </a:xfrm>
+      </p:grpSpPr>
+      <p:sp>
+        <p:nvSpPr>
+          <p:cNvPr id="2" name="Slide Image Placeholder 1"/>
+          <p:cNvSpPr>
+            <a:spLocks noGrp="1"/>
+          </p:cNvSpPr>
+          <p:nvPr>
+            <p:ph type="sldImg" idx="2"/>
+          </p:nvPr>
+        </p:nvSpPr>
+        <p:spPr/>
+      </p:sp>
+      <p:sp>
+        <p:nvSpPr>
+          <p:cNvPr id="3" name="Notes Placeholder 2"/>
+          <p:cNvSpPr>
+            <a:spLocks noGrp="1"/>
+          </p:cNvSpPr>
+          <p:nvPr>
+            <p:ph type="body" idx="3" sz="quarter"/>
+          </p:nvPr>
+        </p:nvSpPr>
+        <p:spPr/>
+        <p:txBody>
+          <a:bodyPr/>
+          <a:lstStyle/>
+          <a:p>
+            <a:r>
+              <a:t>Say the proof bullets, then read the links out loud slowly if this is on screen during the recorded pitch.</a:t>
+            </a:r>
+          </a:p>
+        </p:txBody>
+      </p:sp>
+      <p:sp>
+        <p:nvSpPr>
+          <p:cNvPr id="4" name="Slide Number Placeholder 3"/>
+          <p:cNvSpPr>
+            <a:spLocks noGrp="1"/>
+          </p:cNvSpPr>
+          <p:nvPr>
+            <p:ph type="sldNum" idx="5" sz="quarter"/>
+          </p:nvPr>
+        </p:nvSpPr>
+        <p:spPr/>
+      </p:sp>
+    </p:spTree>
+  </p:cSld>
+  <p:clrMapOvr>
+    <a:masterClrMapping/>
+  </p:clrMapOvr>
+</p:notes>
+</file>
+
+<file path=ppt/notesSlides/notesSlide9.xml><?xml version="1.0" encoding="utf-8"?>
 <p:notes xmlns:a="http://schemas.openxmlformats.org/drawingml/2006/main" xmlns:p="http://schemas.openxmlformats.org/presentationml/2006/main" xmlns:r="http://schemas.openxmlformats.org/officeDocument/2006/relationships">
   <p:cSld>
     <p:spTree>
@@ -4682,13 +4753,13 @@
               </a:lnSpc>
             </a:pPr>
             <a:r>
-              <a:rPr sz="3000" b="1" i="0">
+              <a:rPr sz="3200" b="1" i="0">
                 <a:solidFill>
                   <a:srgbClr val="1F2D22"/>
                 </a:solidFill>
                 <a:latin typeface="Cambria"/>
               </a:rPr>
-              <a:t>Why Screen-Time Apps Don't Work</a:t>
+              <a:t>Our Solution</a:t>
             </a:r>
           </a:p>
         </p:txBody>
@@ -4702,7 +4773,7 @@
         <p:spPr>
           <a:xfrm>
             <a:off x="822960" y="1188720"/>
-            <a:ext cx="9601200" cy="548640"/>
+            <a:ext cx="9784080" cy="548640"/>
           </a:xfrm>
           <a:prstGeom prst="rect">
             <a:avLst/>
@@ -4727,7 +4798,7 @@
                 </a:solidFill>
                 <a:latin typeface="Calibri"/>
               </a:rPr>
-              <a:t>They all take the same approach. We took the opposite one.</a:t>
+              <a:t>Turn proven health habits into earned screen time — nothing unlocks until it's honestly earned.</a:t>
             </a:r>
           </a:p>
         </p:txBody>
@@ -4740,8 +4811,8 @@
         </p:nvSpPr>
         <p:spPr>
           <a:xfrm>
-            <a:off x="822960" y="1920240"/>
-            <a:ext cx="5029200" cy="4114800"/>
+            <a:off x="822960" y="1691640"/>
+            <a:ext cx="3337560" cy="1874519"/>
           </a:xfrm>
           <a:prstGeom prst="roundRect">
             <a:avLst>
@@ -4749,7 +4820,7 @@
             </a:avLst>
           </a:prstGeom>
           <a:solidFill>
-            <a:srgbClr val="ECECEA"/>
+            <a:srgbClr val="DCE8D9"/>
           </a:solidFill>
           <a:ln>
             <a:noFill/>
@@ -4780,204 +4851,20 @@
       </p:sp>
       <p:sp>
         <p:nvSpPr>
-          <p:cNvPr id="5" name="TextBox 4"/>
-          <p:cNvSpPr txBox="1"/>
-          <p:nvPr/>
-        </p:nvSpPr>
-        <p:spPr>
-          <a:xfrm>
-            <a:off x="1097280" y="2148840"/>
-            <a:ext cx="4480560" cy="457200"/>
-          </a:xfrm>
-          <a:prstGeom prst="rect">
-            <a:avLst/>
-          </a:prstGeom>
-          <a:noFill/>
-        </p:spPr>
-        <p:txBody>
-          <a:bodyPr wrap="square" anchor="t" lIns="0" rIns="0" tIns="0" bIns="0">
-            <a:spAutoFit/>
-          </a:bodyPr>
-          <a:lstStyle/>
-          <a:p>
-            <a:pPr algn="l">
-              <a:lnSpc>
-                <a:spcPct val="115000"/>
-              </a:lnSpc>
-            </a:pPr>
-            <a:r>
-              <a:rPr sz="1300" b="1" i="0">
-                <a:solidFill>
-                  <a:srgbClr val="8A8F8B"/>
-                </a:solidFill>
-                <a:latin typeface="Calibri"/>
-              </a:rPr>
-              <a:t>TYPICAL APPS</a:t>
-            </a:r>
-          </a:p>
-        </p:txBody>
-      </p:sp>
-      <p:sp>
-        <p:nvSpPr>
-          <p:cNvPr id="6" name="TextBox 5"/>
-          <p:cNvSpPr txBox="1"/>
-          <p:nvPr/>
-        </p:nvSpPr>
-        <p:spPr>
-          <a:xfrm>
-            <a:off x="1097280" y="2651760"/>
-            <a:ext cx="4480560" cy="3200400"/>
-          </a:xfrm>
-          <a:prstGeom prst="rect">
-            <a:avLst/>
-          </a:prstGeom>
-          <a:noFill/>
-        </p:spPr>
-        <p:txBody>
-          <a:bodyPr wrap="square" lIns="0" rIns="0" tIns="0" bIns="0">
-            <a:spAutoFit/>
-          </a:bodyPr>
-          <a:lstStyle/>
-          <a:p>
-            <a:pPr indent="-201168" marL="201168">
-              <a:lnSpc>
-                <a:spcPct val="115000"/>
-              </a:lnSpc>
-              <a:spcAft>
-                <a:spcPts val="1000"/>
-              </a:spcAft>
-              <a:buClr>
-                <a:srgbClr val="8A8F8B"/>
-              </a:buClr>
-              <a:buFont typeface="Arial"/>
-              <a:buChar char="✗"/>
-            </a:pPr>
-            <a:r>
-              <a:rPr sz="1450">
-                <a:solidFill>
-                  <a:srgbClr val="5B6A5F"/>
-                </a:solidFill>
-                <a:latin typeface="Calibri"/>
-              </a:rPr>
-              <a:t>Restrict access with a hard timer</a:t>
-            </a:r>
-          </a:p>
-          <a:p>
-            <a:pPr indent="-201168" marL="201168">
-              <a:lnSpc>
-                <a:spcPct val="115000"/>
-              </a:lnSpc>
-              <a:spcAft>
-                <a:spcPts val="1000"/>
-              </a:spcAft>
-              <a:buClr>
-                <a:srgbClr val="8A8F8B"/>
-              </a:buClr>
-              <a:buFont typeface="Arial"/>
-              <a:buChar char="✗"/>
-            </a:pPr>
-            <a:r>
-              <a:rPr sz="1450">
-                <a:solidFill>
-                  <a:srgbClr val="5B6A5F"/>
-                </a:solidFill>
-                <a:latin typeface="Calibri"/>
-              </a:rPr>
-              <a:t>Kid feels punished, not motivated</a:t>
-            </a:r>
-          </a:p>
-          <a:p>
-            <a:pPr indent="-201168" marL="201168">
-              <a:lnSpc>
-                <a:spcPct val="115000"/>
-              </a:lnSpc>
-              <a:spcAft>
-                <a:spcPts val="1000"/>
-              </a:spcAft>
-              <a:buClr>
-                <a:srgbClr val="8A8F8B"/>
-              </a:buClr>
-              <a:buFont typeface="Arial"/>
-              <a:buChar char="✗"/>
-            </a:pPr>
-            <a:r>
-              <a:rPr sz="1450">
-                <a:solidFill>
-                  <a:srgbClr val="5B6A5F"/>
-                </a:solidFill>
-                <a:latin typeface="Calibri"/>
-              </a:rPr>
-              <a:t>Parent becomes the enforcer</a:t>
-            </a:r>
-          </a:p>
-          <a:p>
-            <a:pPr indent="-201168" marL="201168">
-              <a:lnSpc>
-                <a:spcPct val="115000"/>
-              </a:lnSpc>
-              <a:spcAft>
-                <a:spcPts val="1000"/>
-              </a:spcAft>
-              <a:buClr>
-                <a:srgbClr val="8A8F8B"/>
-              </a:buClr>
-              <a:buFont typeface="Arial"/>
-              <a:buChar char="✗"/>
-            </a:pPr>
-            <a:r>
-              <a:rPr sz="1450">
-                <a:solidFill>
-                  <a:srgbClr val="5B6A5F"/>
-                </a:solidFill>
-                <a:latin typeface="Calibri"/>
-              </a:rPr>
-              <a:t>One fixed rule for every family</a:t>
-            </a:r>
-          </a:p>
-          <a:p>
-            <a:pPr indent="-201168" marL="201168">
-              <a:lnSpc>
-                <a:spcPct val="115000"/>
-              </a:lnSpc>
-              <a:spcAft>
-                <a:spcPts val="1000"/>
-              </a:spcAft>
-              <a:buClr>
-                <a:srgbClr val="8A8F8B"/>
-              </a:buClr>
-              <a:buFont typeface="Arial"/>
-              <a:buChar char="✗"/>
-            </a:pPr>
-            <a:r>
-              <a:rPr sz="1450">
-                <a:solidFill>
-                  <a:srgbClr val="5B6A5F"/>
-                </a:solidFill>
-                <a:latin typeface="Calibri"/>
-              </a:rPr>
-              <a:t>Screen time becomes a daily fight</a:t>
-            </a:r>
-          </a:p>
-        </p:txBody>
-      </p:sp>
-      <p:sp>
-        <p:nvSpPr>
-          <p:cNvPr id="7" name="Rounded Rectangle 6"/>
+          <p:cNvPr id="5" name="Oval 4"/>
           <p:cNvSpPr/>
           <p:nvPr/>
         </p:nvSpPr>
         <p:spPr>
           <a:xfrm>
-            <a:off x="6309360" y="1920240"/>
-            <a:ext cx="5074920" cy="4114800"/>
-          </a:xfrm>
-          <a:prstGeom prst="roundRect">
-            <a:avLst>
-              <a:gd name="adj" fmla="val 10000"/>
-            </a:avLst>
+            <a:off x="1042416" y="1911096"/>
+            <a:ext cx="566928" cy="566928"/>
+          </a:xfrm>
+          <a:prstGeom prst="ellipse">
+            <a:avLst/>
           </a:prstGeom>
           <a:solidFill>
-            <a:srgbClr val="3E7A5C"/>
+            <a:srgbClr val="FFFFFF"/>
           </a:solidFill>
           <a:ln>
             <a:noFill/>
@@ -4999,23 +4886,70 @@
           </a:fontRef>
         </p:style>
         <p:txBody>
-          <a:bodyPr rtlCol="0" anchor="ctr"/>
+          <a:bodyPr rtlCol="0" anchor="ctr" lIns="0" rIns="0" tIns="0" bIns="0" wrap="none"/>
           <a:lstStyle/>
           <a:p>
             <a:pPr algn="ctr"/>
-          </a:p>
-        </p:txBody>
-      </p:sp>
-      <p:sp>
-        <p:nvSpPr>
-          <p:cNvPr id="8" name="TextBox 7"/>
+            <a:r>
+              <a:rPr sz="1700">
+                <a:solidFill>
+                  <a:srgbClr val="3E7A5C"/>
+                </a:solidFill>
+              </a:rPr>
+              <a:t>🎯</a:t>
+            </a:r>
+          </a:p>
+        </p:txBody>
+      </p:sp>
+      <p:sp>
+        <p:nvSpPr>
+          <p:cNvPr id="6" name="TextBox 5"/>
           <p:cNvSpPr txBox="1"/>
           <p:nvPr/>
         </p:nvSpPr>
         <p:spPr>
           <a:xfrm>
-            <a:off x="6583680" y="2148840"/>
-            <a:ext cx="4480560" cy="457200"/>
+            <a:off x="1691640" y="1929384"/>
+            <a:ext cx="2286000" cy="548640"/>
+          </a:xfrm>
+          <a:prstGeom prst="rect">
+            <a:avLst/>
+          </a:prstGeom>
+          <a:noFill/>
+        </p:spPr>
+        <p:txBody>
+          <a:bodyPr wrap="square" anchor="ctr" lIns="0" rIns="0" tIns="0" bIns="0">
+            <a:spAutoFit/>
+          </a:bodyPr>
+          <a:lstStyle/>
+          <a:p>
+            <a:pPr algn="l">
+              <a:lnSpc>
+                <a:spcPct val="105000"/>
+              </a:lnSpc>
+            </a:pPr>
+            <a:r>
+              <a:rPr sz="1350" b="1" i="0">
+                <a:solidFill>
+                  <a:srgbClr val="1F2D22"/>
+                </a:solidFill>
+                <a:latin typeface="Cambria"/>
+              </a:rPr>
+              <a:t>Motivating, Not Punitive</a:t>
+            </a:r>
+          </a:p>
+        </p:txBody>
+      </p:sp>
+      <p:sp>
+        <p:nvSpPr>
+          <p:cNvPr id="7" name="TextBox 6"/>
+          <p:cNvSpPr txBox="1"/>
+          <p:nvPr/>
+        </p:nvSpPr>
+        <p:spPr>
+          <a:xfrm>
+            <a:off x="1051560" y="2587752"/>
+            <a:ext cx="2880360" cy="822959"/>
           </a:xfrm>
           <a:prstGeom prst="rect">
             <a:avLst/>
@@ -5030,31 +4964,129 @@
           <a:p>
             <a:pPr algn="l">
               <a:lnSpc>
-                <a:spcPct val="115000"/>
+                <a:spcPct val="120000"/>
               </a:lnSpc>
             </a:pPr>
             <a:r>
-              <a:rPr sz="1300" b="1" i="0">
-                <a:solidFill>
-                  <a:srgbClr val="DCE8D9"/>
+              <a:rPr sz="1050" b="0" i="0">
+                <a:solidFill>
+                  <a:srgbClr val="5B6A5F"/>
                 </a:solidFill>
                 <a:latin typeface="Calibri"/>
               </a:rPr>
-              <a:t>HEALTH FIRST</a:t>
-            </a:r>
-          </a:p>
-        </p:txBody>
-      </p:sp>
-      <p:sp>
-        <p:nvSpPr>
-          <p:cNvPr id="9" name="TextBox 8"/>
+              <a:t>Kids earn rewards instead of losing privileges — the opposite of typical restriction apps.</a:t>
+            </a:r>
+          </a:p>
+        </p:txBody>
+      </p:sp>
+      <p:sp>
+        <p:nvSpPr>
+          <p:cNvPr id="8" name="Rounded Rectangle 7"/>
+          <p:cNvSpPr/>
+          <p:nvPr/>
+        </p:nvSpPr>
+        <p:spPr>
+          <a:xfrm>
+            <a:off x="4425696" y="1691640"/>
+            <a:ext cx="3337560" cy="1874519"/>
+          </a:xfrm>
+          <a:prstGeom prst="roundRect">
+            <a:avLst>
+              <a:gd name="adj" fmla="val 10000"/>
+            </a:avLst>
+          </a:prstGeom>
+          <a:solidFill>
+            <a:srgbClr val="F7E1D5"/>
+          </a:solidFill>
+          <a:ln>
+            <a:noFill/>
+          </a:ln>
+          <a:effectLst/>
+        </p:spPr>
+        <p:style>
+          <a:lnRef idx="1">
+            <a:schemeClr val="accent1"/>
+          </a:lnRef>
+          <a:fillRef idx="3">
+            <a:schemeClr val="accent1"/>
+          </a:fillRef>
+          <a:effectRef idx="2">
+            <a:schemeClr val="accent1"/>
+          </a:effectRef>
+          <a:fontRef idx="minor">
+            <a:schemeClr val="lt1"/>
+          </a:fontRef>
+        </p:style>
+        <p:txBody>
+          <a:bodyPr rtlCol="0" anchor="ctr"/>
+          <a:lstStyle/>
+          <a:p>
+            <a:pPr algn="ctr"/>
+          </a:p>
+        </p:txBody>
+      </p:sp>
+      <p:sp>
+        <p:nvSpPr>
+          <p:cNvPr id="9" name="Oval 8"/>
+          <p:cNvSpPr/>
+          <p:nvPr/>
+        </p:nvSpPr>
+        <p:spPr>
+          <a:xfrm>
+            <a:off x="4645152" y="1911096"/>
+            <a:ext cx="566928" cy="566928"/>
+          </a:xfrm>
+          <a:prstGeom prst="ellipse">
+            <a:avLst/>
+          </a:prstGeom>
+          <a:solidFill>
+            <a:srgbClr val="FFFFFF"/>
+          </a:solidFill>
+          <a:ln>
+            <a:noFill/>
+          </a:ln>
+          <a:effectLst/>
+        </p:spPr>
+        <p:style>
+          <a:lnRef idx="1">
+            <a:schemeClr val="accent1"/>
+          </a:lnRef>
+          <a:fillRef idx="3">
+            <a:schemeClr val="accent1"/>
+          </a:fillRef>
+          <a:effectRef idx="2">
+            <a:schemeClr val="accent1"/>
+          </a:effectRef>
+          <a:fontRef idx="minor">
+            <a:schemeClr val="lt1"/>
+          </a:fontRef>
+        </p:style>
+        <p:txBody>
+          <a:bodyPr rtlCol="0" anchor="ctr" lIns="0" rIns="0" tIns="0" bIns="0" wrap="none"/>
+          <a:lstStyle/>
+          <a:p>
+            <a:pPr algn="ctr"/>
+            <a:r>
+              <a:rPr sz="1700">
+                <a:solidFill>
+                  <a:srgbClr val="DD6B42"/>
+                </a:solidFill>
+              </a:rPr>
+              <a:t>🤝</a:t>
+            </a:r>
+          </a:p>
+        </p:txBody>
+      </p:sp>
+      <p:sp>
+        <p:nvSpPr>
+          <p:cNvPr id="10" name="TextBox 9"/>
           <p:cNvSpPr txBox="1"/>
           <p:nvPr/>
         </p:nvSpPr>
         <p:spPr>
           <a:xfrm>
-            <a:off x="6583680" y="2651760"/>
-            <a:ext cx="4480560" cy="3200400"/>
+            <a:off x="5294376" y="1929384"/>
+            <a:ext cx="2286000" cy="548640"/>
           </a:xfrm>
           <a:prstGeom prst="rect">
             <a:avLst/>
@@ -5062,128 +5094,767 @@
           <a:noFill/>
         </p:spPr>
         <p:txBody>
-          <a:bodyPr wrap="square" lIns="0" rIns="0" tIns="0" bIns="0">
+          <a:bodyPr wrap="square" anchor="ctr" lIns="0" rIns="0" tIns="0" bIns="0">
             <a:spAutoFit/>
           </a:bodyPr>
           <a:lstStyle/>
           <a:p>
-            <a:pPr indent="-201168" marL="201168">
+            <a:pPr algn="l">
               <a:lnSpc>
-                <a:spcPct val="115000"/>
+                <a:spcPct val="105000"/>
               </a:lnSpc>
-              <a:spcAft>
-                <a:spcPts val="1000"/>
-              </a:spcAft>
-              <a:buClr>
-                <a:srgbClr val="FFFFFF"/>
-              </a:buClr>
-              <a:buFont typeface="Arial"/>
-              <a:buChar char="✓"/>
             </a:pPr>
             <a:r>
-              <a:rPr sz="1450">
-                <a:solidFill>
-                  <a:srgbClr val="FFFFFF"/>
+              <a:rPr sz="1350" b="1" i="0">
+                <a:solidFill>
+                  <a:srgbClr val="1F2D22"/>
+                </a:solidFill>
+                <a:latin typeface="Cambria"/>
+              </a:rPr>
+              <a:t>Less Family Conflict</a:t>
+            </a:r>
+          </a:p>
+        </p:txBody>
+      </p:sp>
+      <p:sp>
+        <p:nvSpPr>
+          <p:cNvPr id="11" name="TextBox 10"/>
+          <p:cNvSpPr txBox="1"/>
+          <p:nvPr/>
+        </p:nvSpPr>
+        <p:spPr>
+          <a:xfrm>
+            <a:off x="4654296" y="2587752"/>
+            <a:ext cx="2880360" cy="822959"/>
+          </a:xfrm>
+          <a:prstGeom prst="rect">
+            <a:avLst/>
+          </a:prstGeom>
+          <a:noFill/>
+        </p:spPr>
+        <p:txBody>
+          <a:bodyPr wrap="square" anchor="t" lIns="0" rIns="0" tIns="0" bIns="0">
+            <a:spAutoFit/>
+          </a:bodyPr>
+          <a:lstStyle/>
+          <a:p>
+            <a:pPr algn="l">
+              <a:lnSpc>
+                <a:spcPct val="120000"/>
+              </a:lnSpc>
+            </a:pPr>
+            <a:r>
+              <a:rPr sz="1050" b="0" i="0">
+                <a:solidFill>
+                  <a:srgbClr val="5B6A5F"/>
                 </a:solidFill>
                 <a:latin typeface="Calibri"/>
               </a:rPr>
-              <a:t>Rewards healthy habits with earned time</a:t>
-            </a:r>
-          </a:p>
-          <a:p>
-            <a:pPr indent="-201168" marL="201168">
+              <a:t>Screen time becomes a shared goal between parent and kid, not a daily fight.</a:t>
+            </a:r>
+          </a:p>
+        </p:txBody>
+      </p:sp>
+      <p:sp>
+        <p:nvSpPr>
+          <p:cNvPr id="12" name="Rounded Rectangle 11"/>
+          <p:cNvSpPr/>
+          <p:nvPr/>
+        </p:nvSpPr>
+        <p:spPr>
+          <a:xfrm>
+            <a:off x="8037575" y="1691640"/>
+            <a:ext cx="3337560" cy="1874519"/>
+          </a:xfrm>
+          <a:prstGeom prst="roundRect">
+            <a:avLst>
+              <a:gd name="adj" fmla="val 10000"/>
+            </a:avLst>
+          </a:prstGeom>
+          <a:solidFill>
+            <a:srgbClr val="F5E7C9"/>
+          </a:solidFill>
+          <a:ln>
+            <a:noFill/>
+          </a:ln>
+          <a:effectLst/>
+        </p:spPr>
+        <p:style>
+          <a:lnRef idx="1">
+            <a:schemeClr val="accent1"/>
+          </a:lnRef>
+          <a:fillRef idx="3">
+            <a:schemeClr val="accent1"/>
+          </a:fillRef>
+          <a:effectRef idx="2">
+            <a:schemeClr val="accent1"/>
+          </a:effectRef>
+          <a:fontRef idx="minor">
+            <a:schemeClr val="lt1"/>
+          </a:fontRef>
+        </p:style>
+        <p:txBody>
+          <a:bodyPr rtlCol="0" anchor="ctr"/>
+          <a:lstStyle/>
+          <a:p>
+            <a:pPr algn="ctr"/>
+          </a:p>
+        </p:txBody>
+      </p:sp>
+      <p:sp>
+        <p:nvSpPr>
+          <p:cNvPr id="13" name="Oval 12"/>
+          <p:cNvSpPr/>
+          <p:nvPr/>
+        </p:nvSpPr>
+        <p:spPr>
+          <a:xfrm>
+            <a:off x="8257031" y="1911096"/>
+            <a:ext cx="566928" cy="566928"/>
+          </a:xfrm>
+          <a:prstGeom prst="ellipse">
+            <a:avLst/>
+          </a:prstGeom>
+          <a:solidFill>
+            <a:srgbClr val="FFFFFF"/>
+          </a:solidFill>
+          <a:ln>
+            <a:noFill/>
+          </a:ln>
+          <a:effectLst/>
+        </p:spPr>
+        <p:style>
+          <a:lnRef idx="1">
+            <a:schemeClr val="accent1"/>
+          </a:lnRef>
+          <a:fillRef idx="3">
+            <a:schemeClr val="accent1"/>
+          </a:fillRef>
+          <a:effectRef idx="2">
+            <a:schemeClr val="accent1"/>
+          </a:effectRef>
+          <a:fontRef idx="minor">
+            <a:schemeClr val="lt1"/>
+          </a:fontRef>
+        </p:style>
+        <p:txBody>
+          <a:bodyPr rtlCol="0" anchor="ctr" lIns="0" rIns="0" tIns="0" bIns="0" wrap="none"/>
+          <a:lstStyle/>
+          <a:p>
+            <a:pPr algn="ctr"/>
+            <a:r>
+              <a:rPr sz="1700">
+                <a:solidFill>
+                  <a:srgbClr val="DB9D3B"/>
+                </a:solidFill>
+              </a:rPr>
+              <a:t>🔧</a:t>
+            </a:r>
+          </a:p>
+        </p:txBody>
+      </p:sp>
+      <p:sp>
+        <p:nvSpPr>
+          <p:cNvPr id="14" name="TextBox 13"/>
+          <p:cNvSpPr txBox="1"/>
+          <p:nvPr/>
+        </p:nvSpPr>
+        <p:spPr>
+          <a:xfrm>
+            <a:off x="8906255" y="1929384"/>
+            <a:ext cx="2286000" cy="548640"/>
+          </a:xfrm>
+          <a:prstGeom prst="rect">
+            <a:avLst/>
+          </a:prstGeom>
+          <a:noFill/>
+        </p:spPr>
+        <p:txBody>
+          <a:bodyPr wrap="square" anchor="ctr" lIns="0" rIns="0" tIns="0" bIns="0">
+            <a:spAutoFit/>
+          </a:bodyPr>
+          <a:lstStyle/>
+          <a:p>
+            <a:pPr algn="l">
               <a:lnSpc>
-                <a:spcPct val="115000"/>
+                <a:spcPct val="105000"/>
               </a:lnSpc>
-              <a:spcAft>
-                <a:spcPts val="1000"/>
-              </a:spcAft>
-              <a:buClr>
-                <a:srgbClr val="FFFFFF"/>
-              </a:buClr>
-              <a:buFont typeface="Arial"/>
-              <a:buChar char="✓"/>
             </a:pPr>
             <a:r>
-              <a:rPr sz="1450">
-                <a:solidFill>
-                  <a:srgbClr val="FFFFFF"/>
+              <a:rPr sz="1350" b="1" i="0">
+                <a:solidFill>
+                  <a:srgbClr val="1F2D22"/>
+                </a:solidFill>
+                <a:latin typeface="Cambria"/>
+              </a:rPr>
+              <a:t>Fully Customizable</a:t>
+            </a:r>
+          </a:p>
+        </p:txBody>
+      </p:sp>
+      <p:sp>
+        <p:nvSpPr>
+          <p:cNvPr id="15" name="TextBox 14"/>
+          <p:cNvSpPr txBox="1"/>
+          <p:nvPr/>
+        </p:nvSpPr>
+        <p:spPr>
+          <a:xfrm>
+            <a:off x="8266175" y="2587752"/>
+            <a:ext cx="2880360" cy="822959"/>
+          </a:xfrm>
+          <a:prstGeom prst="rect">
+            <a:avLst/>
+          </a:prstGeom>
+          <a:noFill/>
+        </p:spPr>
+        <p:txBody>
+          <a:bodyPr wrap="square" anchor="t" lIns="0" rIns="0" tIns="0" bIns="0">
+            <a:spAutoFit/>
+          </a:bodyPr>
+          <a:lstStyle/>
+          <a:p>
+            <a:pPr algn="l">
+              <a:lnSpc>
+                <a:spcPct val="120000"/>
+              </a:lnSpc>
+            </a:pPr>
+            <a:r>
+              <a:rPr sz="1050" b="0" i="0">
+                <a:solidFill>
+                  <a:srgbClr val="5B6A5F"/>
                 </a:solidFill>
                 <a:latin typeface="Calibri"/>
               </a:rPr>
-              <a:t>Kid feels motivated by immediate credit</a:t>
-            </a:r>
-          </a:p>
-          <a:p>
-            <a:pPr indent="-201168" marL="201168">
+              <a:t>Parents set their own goals and exactly how many minutes each one is worth.</a:t>
+            </a:r>
+          </a:p>
+        </p:txBody>
+      </p:sp>
+      <p:sp>
+        <p:nvSpPr>
+          <p:cNvPr id="16" name="Rounded Rectangle 15"/>
+          <p:cNvSpPr/>
+          <p:nvPr/>
+        </p:nvSpPr>
+        <p:spPr>
+          <a:xfrm>
+            <a:off x="822960" y="3794760"/>
+            <a:ext cx="3337560" cy="1874519"/>
+          </a:xfrm>
+          <a:prstGeom prst="roundRect">
+            <a:avLst>
+              <a:gd name="adj" fmla="val 10000"/>
+            </a:avLst>
+          </a:prstGeom>
+          <a:solidFill>
+            <a:srgbClr val="E2E2F5"/>
+          </a:solidFill>
+          <a:ln>
+            <a:noFill/>
+          </a:ln>
+          <a:effectLst/>
+        </p:spPr>
+        <p:style>
+          <a:lnRef idx="1">
+            <a:schemeClr val="accent1"/>
+          </a:lnRef>
+          <a:fillRef idx="3">
+            <a:schemeClr val="accent1"/>
+          </a:fillRef>
+          <a:effectRef idx="2">
+            <a:schemeClr val="accent1"/>
+          </a:effectRef>
+          <a:fontRef idx="minor">
+            <a:schemeClr val="lt1"/>
+          </a:fontRef>
+        </p:style>
+        <p:txBody>
+          <a:bodyPr rtlCol="0" anchor="ctr"/>
+          <a:lstStyle/>
+          <a:p>
+            <a:pPr algn="ctr"/>
+          </a:p>
+        </p:txBody>
+      </p:sp>
+      <p:sp>
+        <p:nvSpPr>
+          <p:cNvPr id="17" name="Oval 16"/>
+          <p:cNvSpPr/>
+          <p:nvPr/>
+        </p:nvSpPr>
+        <p:spPr>
+          <a:xfrm>
+            <a:off x="1042416" y="4014216"/>
+            <a:ext cx="566928" cy="566928"/>
+          </a:xfrm>
+          <a:prstGeom prst="ellipse">
+            <a:avLst/>
+          </a:prstGeom>
+          <a:solidFill>
+            <a:srgbClr val="FFFFFF"/>
+          </a:solidFill>
+          <a:ln>
+            <a:noFill/>
+          </a:ln>
+          <a:effectLst/>
+        </p:spPr>
+        <p:style>
+          <a:lnRef idx="1">
+            <a:schemeClr val="accent1"/>
+          </a:lnRef>
+          <a:fillRef idx="3">
+            <a:schemeClr val="accent1"/>
+          </a:fillRef>
+          <a:effectRef idx="2">
+            <a:schemeClr val="accent1"/>
+          </a:effectRef>
+          <a:fontRef idx="minor">
+            <a:schemeClr val="lt1"/>
+          </a:fontRef>
+        </p:style>
+        <p:txBody>
+          <a:bodyPr rtlCol="0" anchor="ctr" lIns="0" rIns="0" tIns="0" bIns="0" wrap="none"/>
+          <a:lstStyle/>
+          <a:p>
+            <a:pPr algn="ctr"/>
+            <a:r>
+              <a:rPr sz="1700">
+                <a:solidFill>
+                  <a:srgbClr val="6E6FBF"/>
+                </a:solidFill>
+              </a:rPr>
+              <a:t>📈</a:t>
+            </a:r>
+          </a:p>
+        </p:txBody>
+      </p:sp>
+      <p:sp>
+        <p:nvSpPr>
+          <p:cNvPr id="18" name="TextBox 17"/>
+          <p:cNvSpPr txBox="1"/>
+          <p:nvPr/>
+        </p:nvSpPr>
+        <p:spPr>
+          <a:xfrm>
+            <a:off x="1691640" y="4032504"/>
+            <a:ext cx="2286000" cy="548640"/>
+          </a:xfrm>
+          <a:prstGeom prst="rect">
+            <a:avLst/>
+          </a:prstGeom>
+          <a:noFill/>
+        </p:spPr>
+        <p:txBody>
+          <a:bodyPr wrap="square" anchor="ctr" lIns="0" rIns="0" tIns="0" bIns="0">
+            <a:spAutoFit/>
+          </a:bodyPr>
+          <a:lstStyle/>
+          <a:p>
+            <a:pPr algn="l">
               <a:lnSpc>
-                <a:spcPct val="115000"/>
+                <a:spcPct val="105000"/>
               </a:lnSpc>
-              <a:spcAft>
-                <a:spcPts val="1000"/>
-              </a:spcAft>
-              <a:buClr>
-                <a:srgbClr val="FFFFFF"/>
-              </a:buClr>
-              <a:buFont typeface="Arial"/>
-              <a:buChar char="✓"/>
             </a:pPr>
             <a:r>
-              <a:rPr sz="1450">
-                <a:solidFill>
-                  <a:srgbClr val="FFFFFF"/>
+              <a:rPr sz="1350" b="1" i="0">
+                <a:solidFill>
+                  <a:srgbClr val="1F2D22"/>
+                </a:solidFill>
+                <a:latin typeface="Cambria"/>
+              </a:rPr>
+              <a:t>Builds Real Habits</a:t>
+            </a:r>
+          </a:p>
+        </p:txBody>
+      </p:sp>
+      <p:sp>
+        <p:nvSpPr>
+          <p:cNvPr id="19" name="TextBox 18"/>
+          <p:cNvSpPr txBox="1"/>
+          <p:nvPr/>
+        </p:nvSpPr>
+        <p:spPr>
+          <a:xfrm>
+            <a:off x="1051560" y="4690872"/>
+            <a:ext cx="2880360" cy="822959"/>
+          </a:xfrm>
+          <a:prstGeom prst="rect">
+            <a:avLst/>
+          </a:prstGeom>
+          <a:noFill/>
+        </p:spPr>
+        <p:txBody>
+          <a:bodyPr wrap="square" anchor="t" lIns="0" rIns="0" tIns="0" bIns="0">
+            <a:spAutoFit/>
+          </a:bodyPr>
+          <a:lstStyle/>
+          <a:p>
+            <a:pPr algn="l">
+              <a:lnSpc>
+                <a:spcPct val="120000"/>
+              </a:lnSpc>
+            </a:pPr>
+            <a:r>
+              <a:rPr sz="1050" b="0" i="0">
+                <a:solidFill>
+                  <a:srgbClr val="5B6A5F"/>
                 </a:solidFill>
                 <a:latin typeface="Calibri"/>
               </a:rPr>
-              <a:t>Parent becomes a coach, not a warden</a:t>
-            </a:r>
-          </a:p>
-          <a:p>
-            <a:pPr indent="-201168" marL="201168">
+              <a:t>Daily repetition plus streaks reinforce long-term behavior change, not one-off compliance.</a:t>
+            </a:r>
+          </a:p>
+        </p:txBody>
+      </p:sp>
+      <p:sp>
+        <p:nvSpPr>
+          <p:cNvPr id="20" name="Rounded Rectangle 19"/>
+          <p:cNvSpPr/>
+          <p:nvPr/>
+        </p:nvSpPr>
+        <p:spPr>
+          <a:xfrm>
+            <a:off x="4425696" y="3794760"/>
+            <a:ext cx="3337560" cy="1874519"/>
+          </a:xfrm>
+          <a:prstGeom prst="roundRect">
+            <a:avLst>
+              <a:gd name="adj" fmla="val 10000"/>
+            </a:avLst>
+          </a:prstGeom>
+          <a:solidFill>
+            <a:srgbClr val="F7E1D5"/>
+          </a:solidFill>
+          <a:ln>
+            <a:noFill/>
+          </a:ln>
+          <a:effectLst/>
+        </p:spPr>
+        <p:style>
+          <a:lnRef idx="1">
+            <a:schemeClr val="accent1"/>
+          </a:lnRef>
+          <a:fillRef idx="3">
+            <a:schemeClr val="accent1"/>
+          </a:fillRef>
+          <a:effectRef idx="2">
+            <a:schemeClr val="accent1"/>
+          </a:effectRef>
+          <a:fontRef idx="minor">
+            <a:schemeClr val="lt1"/>
+          </a:fontRef>
+        </p:style>
+        <p:txBody>
+          <a:bodyPr rtlCol="0" anchor="ctr"/>
+          <a:lstStyle/>
+          <a:p>
+            <a:pPr algn="ctr"/>
+          </a:p>
+        </p:txBody>
+      </p:sp>
+      <p:sp>
+        <p:nvSpPr>
+          <p:cNvPr id="21" name="Oval 20"/>
+          <p:cNvSpPr/>
+          <p:nvPr/>
+        </p:nvSpPr>
+        <p:spPr>
+          <a:xfrm>
+            <a:off x="4645152" y="4014216"/>
+            <a:ext cx="566928" cy="566928"/>
+          </a:xfrm>
+          <a:prstGeom prst="ellipse">
+            <a:avLst/>
+          </a:prstGeom>
+          <a:solidFill>
+            <a:srgbClr val="FFFFFF"/>
+          </a:solidFill>
+          <a:ln>
+            <a:noFill/>
+          </a:ln>
+          <a:effectLst/>
+        </p:spPr>
+        <p:style>
+          <a:lnRef idx="1">
+            <a:schemeClr val="accent1"/>
+          </a:lnRef>
+          <a:fillRef idx="3">
+            <a:schemeClr val="accent1"/>
+          </a:fillRef>
+          <a:effectRef idx="2">
+            <a:schemeClr val="accent1"/>
+          </a:effectRef>
+          <a:fontRef idx="minor">
+            <a:schemeClr val="lt1"/>
+          </a:fontRef>
+        </p:style>
+        <p:txBody>
+          <a:bodyPr rtlCol="0" anchor="ctr" lIns="0" rIns="0" tIns="0" bIns="0" wrap="none"/>
+          <a:lstStyle/>
+          <a:p>
+            <a:pPr algn="ctr"/>
+            <a:r>
+              <a:rPr sz="1700">
+                <a:solidFill>
+                  <a:srgbClr val="DD6B42"/>
+                </a:solidFill>
+              </a:rPr>
+              <a:t>⚖️</a:t>
+            </a:r>
+          </a:p>
+        </p:txBody>
+      </p:sp>
+      <p:sp>
+        <p:nvSpPr>
+          <p:cNvPr id="22" name="TextBox 21"/>
+          <p:cNvSpPr txBox="1"/>
+          <p:nvPr/>
+        </p:nvSpPr>
+        <p:spPr>
+          <a:xfrm>
+            <a:off x="5294376" y="4032504"/>
+            <a:ext cx="2286000" cy="548640"/>
+          </a:xfrm>
+          <a:prstGeom prst="rect">
+            <a:avLst/>
+          </a:prstGeom>
+          <a:noFill/>
+        </p:spPr>
+        <p:txBody>
+          <a:bodyPr wrap="square" anchor="ctr" lIns="0" rIns="0" tIns="0" bIns="0">
+            <a:spAutoFit/>
+          </a:bodyPr>
+          <a:lstStyle/>
+          <a:p>
+            <a:pPr algn="l">
               <a:lnSpc>
-                <a:spcPct val="115000"/>
+                <a:spcPct val="105000"/>
               </a:lnSpc>
-              <a:spcAft>
-                <a:spcPts val="1000"/>
-              </a:spcAft>
-              <a:buClr>
-                <a:srgbClr val="FFFFFF"/>
-              </a:buClr>
-              <a:buFont typeface="Arial"/>
-              <a:buChar char="✓"/>
             </a:pPr>
             <a:r>
-              <a:rPr sz="1450">
-                <a:solidFill>
-                  <a:srgbClr val="FFFFFF"/>
+              <a:rPr sz="1350" b="1" i="0">
+                <a:solidFill>
+                  <a:srgbClr val="1F2D22"/>
+                </a:solidFill>
+                <a:latin typeface="Cambria"/>
+              </a:rPr>
+              <a:t>Fair &amp; Honest</a:t>
+            </a:r>
+          </a:p>
+        </p:txBody>
+      </p:sp>
+      <p:sp>
+        <p:nvSpPr>
+          <p:cNvPr id="23" name="TextBox 22"/>
+          <p:cNvSpPr txBox="1"/>
+          <p:nvPr/>
+        </p:nvSpPr>
+        <p:spPr>
+          <a:xfrm>
+            <a:off x="4654296" y="4690872"/>
+            <a:ext cx="2880360" cy="822959"/>
+          </a:xfrm>
+          <a:prstGeom prst="rect">
+            <a:avLst/>
+          </a:prstGeom>
+          <a:noFill/>
+        </p:spPr>
+        <p:txBody>
+          <a:bodyPr wrap="square" anchor="t" lIns="0" rIns="0" tIns="0" bIns="0">
+            <a:spAutoFit/>
+          </a:bodyPr>
+          <a:lstStyle/>
+          <a:p>
+            <a:pPr algn="l">
+              <a:lnSpc>
+                <a:spcPct val="120000"/>
+              </a:lnSpc>
+            </a:pPr>
+            <a:r>
+              <a:rPr sz="1050" b="0" i="0">
+                <a:solidFill>
+                  <a:srgbClr val="5B6A5F"/>
                 </a:solidFill>
                 <a:latin typeface="Calibri"/>
               </a:rPr>
-              <a:t>Every goal and reward is configurable</a:t>
-            </a:r>
-          </a:p>
-          <a:p>
-            <a:pPr indent="-201168" marL="201168">
+              <a:t>Partial effort still banks time — one missed goal doesn't erase the whole day.</a:t>
+            </a:r>
+          </a:p>
+        </p:txBody>
+      </p:sp>
+      <p:sp>
+        <p:nvSpPr>
+          <p:cNvPr id="24" name="Rounded Rectangle 23"/>
+          <p:cNvSpPr/>
+          <p:nvPr/>
+        </p:nvSpPr>
+        <p:spPr>
+          <a:xfrm>
+            <a:off x="8037575" y="3794760"/>
+            <a:ext cx="3337560" cy="1874519"/>
+          </a:xfrm>
+          <a:prstGeom prst="roundRect">
+            <a:avLst>
+              <a:gd name="adj" fmla="val 10000"/>
+            </a:avLst>
+          </a:prstGeom>
+          <a:solidFill>
+            <a:srgbClr val="DCE8D9"/>
+          </a:solidFill>
+          <a:ln>
+            <a:noFill/>
+          </a:ln>
+          <a:effectLst/>
+        </p:spPr>
+        <p:style>
+          <a:lnRef idx="1">
+            <a:schemeClr val="accent1"/>
+          </a:lnRef>
+          <a:fillRef idx="3">
+            <a:schemeClr val="accent1"/>
+          </a:fillRef>
+          <a:effectRef idx="2">
+            <a:schemeClr val="accent1"/>
+          </a:effectRef>
+          <a:fontRef idx="minor">
+            <a:schemeClr val="lt1"/>
+          </a:fontRef>
+        </p:style>
+        <p:txBody>
+          <a:bodyPr rtlCol="0" anchor="ctr"/>
+          <a:lstStyle/>
+          <a:p>
+            <a:pPr algn="ctr"/>
+          </a:p>
+        </p:txBody>
+      </p:sp>
+      <p:sp>
+        <p:nvSpPr>
+          <p:cNvPr id="25" name="Oval 24"/>
+          <p:cNvSpPr/>
+          <p:nvPr/>
+        </p:nvSpPr>
+        <p:spPr>
+          <a:xfrm>
+            <a:off x="8257031" y="4014216"/>
+            <a:ext cx="566928" cy="566928"/>
+          </a:xfrm>
+          <a:prstGeom prst="ellipse">
+            <a:avLst/>
+          </a:prstGeom>
+          <a:solidFill>
+            <a:srgbClr val="FFFFFF"/>
+          </a:solidFill>
+          <a:ln>
+            <a:noFill/>
+          </a:ln>
+          <a:effectLst/>
+        </p:spPr>
+        <p:style>
+          <a:lnRef idx="1">
+            <a:schemeClr val="accent1"/>
+          </a:lnRef>
+          <a:fillRef idx="3">
+            <a:schemeClr val="accent1"/>
+          </a:fillRef>
+          <a:effectRef idx="2">
+            <a:schemeClr val="accent1"/>
+          </a:effectRef>
+          <a:fontRef idx="minor">
+            <a:schemeClr val="lt1"/>
+          </a:fontRef>
+        </p:style>
+        <p:txBody>
+          <a:bodyPr rtlCol="0" anchor="ctr" lIns="0" rIns="0" tIns="0" bIns="0" wrap="none"/>
+          <a:lstStyle/>
+          <a:p>
+            <a:pPr algn="ctr"/>
+            <a:r>
+              <a:rPr sz="1700">
+                <a:solidFill>
+                  <a:srgbClr val="3E7A5C"/>
+                </a:solidFill>
+              </a:rPr>
+              <a:t>🌍</a:t>
+            </a:r>
+          </a:p>
+        </p:txBody>
+      </p:sp>
+      <p:sp>
+        <p:nvSpPr>
+          <p:cNvPr id="26" name="TextBox 25"/>
+          <p:cNvSpPr txBox="1"/>
+          <p:nvPr/>
+        </p:nvSpPr>
+        <p:spPr>
+          <a:xfrm>
+            <a:off x="8906255" y="4032504"/>
+            <a:ext cx="2286000" cy="548640"/>
+          </a:xfrm>
+          <a:prstGeom prst="rect">
+            <a:avLst/>
+          </a:prstGeom>
+          <a:noFill/>
+        </p:spPr>
+        <p:txBody>
+          <a:bodyPr wrap="square" anchor="ctr" lIns="0" rIns="0" tIns="0" bIns="0">
+            <a:spAutoFit/>
+          </a:bodyPr>
+          <a:lstStyle/>
+          <a:p>
+            <a:pPr algn="l">
               <a:lnSpc>
-                <a:spcPct val="115000"/>
+                <a:spcPct val="105000"/>
               </a:lnSpc>
-              <a:spcAft>
-                <a:spcPts val="1000"/>
-              </a:spcAft>
-              <a:buClr>
-                <a:srgbClr val="FFFFFF"/>
-              </a:buClr>
-              <a:buFont typeface="Arial"/>
-              <a:buChar char="✓"/>
             </a:pPr>
             <a:r>
-              <a:rPr sz="1450">
-                <a:solidFill>
-                  <a:srgbClr val="FFFFFF"/>
+              <a:rPr sz="1350" b="1" i="0">
+                <a:solidFill>
+                  <a:srgbClr val="1F2D22"/>
+                </a:solidFill>
+                <a:latin typeface="Cambria"/>
+              </a:rPr>
+              <a:t>Works for Any Family</a:t>
+            </a:r>
+          </a:p>
+        </p:txBody>
+      </p:sp>
+      <p:sp>
+        <p:nvSpPr>
+          <p:cNvPr id="27" name="TextBox 26"/>
+          <p:cNvSpPr txBox="1"/>
+          <p:nvPr/>
+        </p:nvSpPr>
+        <p:spPr>
+          <a:xfrm>
+            <a:off x="8266175" y="4690872"/>
+            <a:ext cx="2880360" cy="822959"/>
+          </a:xfrm>
+          <a:prstGeom prst="rect">
+            <a:avLst/>
+          </a:prstGeom>
+          <a:noFill/>
+        </p:spPr>
+        <p:txBody>
+          <a:bodyPr wrap="square" anchor="t" lIns="0" rIns="0" tIns="0" bIns="0">
+            <a:spAutoFit/>
+          </a:bodyPr>
+          <a:lstStyle/>
+          <a:p>
+            <a:pPr algn="l">
+              <a:lnSpc>
+                <a:spcPct val="120000"/>
+              </a:lnSpc>
+            </a:pPr>
+            <a:r>
+              <a:rPr sz="1050" b="0" i="0">
+                <a:solidFill>
+                  <a:srgbClr val="5B6A5F"/>
                 </a:solidFill>
                 <a:latin typeface="Calibri"/>
               </a:rPr>
-              <a:t>Screen time becomes a shared goal</a:t>
+              <a:t>No fixed rules — adapts to each household's own goals and routines.</a:t>
             </a:r>
           </a:p>
         </p:txBody>
@@ -5223,7 +5894,7 @@
         <p:spPr>
           <a:xfrm>
             <a:off x="822960" y="502920"/>
-            <a:ext cx="7315200" cy="548640"/>
+            <a:ext cx="10332720" cy="731520"/>
           </a:xfrm>
           <a:prstGeom prst="rect">
             <a:avLst/>
@@ -5248,7 +5919,7 @@
                 </a:solidFill>
                 <a:latin typeface="Cambria"/>
               </a:rPr>
-              <a:t>How It Works</a:t>
+              <a:t>Why Screen-Time Apps Don't Work</a:t>
             </a:r>
           </a:p>
         </p:txBody>
@@ -5261,7 +5932,7 @@
         </p:nvSpPr>
         <p:spPr>
           <a:xfrm>
-            <a:off x="822960" y="1143000"/>
+            <a:off x="822960" y="1188720"/>
             <a:ext cx="9601200" cy="548640"/>
           </a:xfrm>
           <a:prstGeom prst="rect">
@@ -5287,27 +5958,29 @@
                 </a:solidFill>
                 <a:latin typeface="Calibri"/>
               </a:rPr>
-              <a:t>A daily checklist of health goals — proven honestly — banks screen time.</a:t>
-            </a:r>
-          </a:p>
-        </p:txBody>
-      </p:sp>
-      <p:sp>
-        <p:nvSpPr>
-          <p:cNvPr id="4" name="Oval 3"/>
+              <a:t>They all take the same approach. We took the opposite one.</a:t>
+            </a:r>
+          </a:p>
+        </p:txBody>
+      </p:sp>
+      <p:sp>
+        <p:nvSpPr>
+          <p:cNvPr id="4" name="Rounded Rectangle 3"/>
           <p:cNvSpPr/>
           <p:nvPr/>
         </p:nvSpPr>
         <p:spPr>
           <a:xfrm>
-            <a:off x="1280160" y="1965960"/>
-            <a:ext cx="1097280" cy="1097280"/>
-          </a:xfrm>
-          <a:prstGeom prst="ellipse">
-            <a:avLst/>
+            <a:off x="822960" y="1920240"/>
+            <a:ext cx="5029200" cy="4114800"/>
+          </a:xfrm>
+          <a:prstGeom prst="roundRect">
+            <a:avLst>
+              <a:gd name="adj" fmla="val 10000"/>
+            </a:avLst>
           </a:prstGeom>
           <a:solidFill>
-            <a:srgbClr val="DCE8D9"/>
+            <a:srgbClr val="ECECEA"/>
           </a:solidFill>
           <a:ln>
             <a:noFill/>
@@ -5329,18 +6002,10 @@
           </a:fontRef>
         </p:style>
         <p:txBody>
-          <a:bodyPr rtlCol="0" anchor="ctr" lIns="0" rIns="0" tIns="0" bIns="0" wrap="none"/>
+          <a:bodyPr rtlCol="0" anchor="ctr"/>
           <a:lstStyle/>
           <a:p>
             <a:pPr algn="ctr"/>
-            <a:r>
-              <a:rPr sz="3300">
-                <a:solidFill>
-                  <a:srgbClr val="3E7A5C"/>
-                </a:solidFill>
-              </a:rPr>
-              <a:t>💧</a:t>
-            </a:r>
           </a:p>
         </p:txBody>
       </p:sp>
@@ -5352,8 +6017,8 @@
         </p:nvSpPr>
         <p:spPr>
           <a:xfrm>
-            <a:off x="1005840" y="3154680"/>
-            <a:ext cx="1645920" cy="365760"/>
+            <a:off x="1097280" y="2148840"/>
+            <a:ext cx="4480560" cy="457200"/>
           </a:xfrm>
           <a:prstGeom prst="rect">
             <a:avLst/>
@@ -5366,39 +6031,184 @@
           </a:bodyPr>
           <a:lstStyle/>
           <a:p>
-            <a:pPr algn="ctr">
+            <a:pPr algn="l">
               <a:lnSpc>
                 <a:spcPct val="115000"/>
               </a:lnSpc>
             </a:pPr>
             <a:r>
-              <a:rPr sz="1400" b="1" i="0">
-                <a:solidFill>
-                  <a:srgbClr val="1F2D22"/>
+              <a:rPr sz="1300" b="1" i="0">
+                <a:solidFill>
+                  <a:srgbClr val="8A8F8B"/>
                 </a:solidFill>
                 <a:latin typeface="Calibri"/>
               </a:rPr>
-              <a:t>Water</a:t>
-            </a:r>
-          </a:p>
-        </p:txBody>
-      </p:sp>
-      <p:sp>
-        <p:nvSpPr>
-          <p:cNvPr id="6" name="Oval 5"/>
+              <a:t>TYPICAL APPS</a:t>
+            </a:r>
+          </a:p>
+        </p:txBody>
+      </p:sp>
+      <p:sp>
+        <p:nvSpPr>
+          <p:cNvPr id="6" name="TextBox 5"/>
+          <p:cNvSpPr txBox="1"/>
+          <p:nvPr/>
+        </p:nvSpPr>
+        <p:spPr>
+          <a:xfrm>
+            <a:off x="1097280" y="2651760"/>
+            <a:ext cx="4480560" cy="3200400"/>
+          </a:xfrm>
+          <a:prstGeom prst="rect">
+            <a:avLst/>
+          </a:prstGeom>
+          <a:noFill/>
+        </p:spPr>
+        <p:txBody>
+          <a:bodyPr wrap="square" lIns="0" rIns="0" tIns="0" bIns="0">
+            <a:spAutoFit/>
+          </a:bodyPr>
+          <a:lstStyle/>
+          <a:p>
+            <a:pPr indent="-201168" marL="201168">
+              <a:lnSpc>
+                <a:spcPct val="115000"/>
+              </a:lnSpc>
+              <a:spcAft>
+                <a:spcPts val="1000"/>
+              </a:spcAft>
+              <a:buClr>
+                <a:srgbClr val="8A8F8B"/>
+              </a:buClr>
+              <a:buFont typeface="Arial"/>
+              <a:buChar char="✗"/>
+            </a:pPr>
+            <a:r>
+              <a:rPr sz="1450">
+                <a:solidFill>
+                  <a:srgbClr val="5B6A5F"/>
+                </a:solidFill>
+                <a:latin typeface="Calibri"/>
+              </a:rPr>
+              <a:t>Restrict access with a hard timer</a:t>
+            </a:r>
+          </a:p>
+          <a:p>
+            <a:pPr indent="-201168" marL="201168">
+              <a:lnSpc>
+                <a:spcPct val="115000"/>
+              </a:lnSpc>
+              <a:spcAft>
+                <a:spcPts val="1000"/>
+              </a:spcAft>
+              <a:buClr>
+                <a:srgbClr val="8A8F8B"/>
+              </a:buClr>
+              <a:buFont typeface="Arial"/>
+              <a:buChar char="✗"/>
+            </a:pPr>
+            <a:r>
+              <a:rPr sz="1450">
+                <a:solidFill>
+                  <a:srgbClr val="5B6A5F"/>
+                </a:solidFill>
+                <a:latin typeface="Calibri"/>
+              </a:rPr>
+              <a:t>Kid feels punished, not motivated</a:t>
+            </a:r>
+          </a:p>
+          <a:p>
+            <a:pPr indent="-201168" marL="201168">
+              <a:lnSpc>
+                <a:spcPct val="115000"/>
+              </a:lnSpc>
+              <a:spcAft>
+                <a:spcPts val="1000"/>
+              </a:spcAft>
+              <a:buClr>
+                <a:srgbClr val="8A8F8B"/>
+              </a:buClr>
+              <a:buFont typeface="Arial"/>
+              <a:buChar char="✗"/>
+            </a:pPr>
+            <a:r>
+              <a:rPr sz="1450">
+                <a:solidFill>
+                  <a:srgbClr val="5B6A5F"/>
+                </a:solidFill>
+                <a:latin typeface="Calibri"/>
+              </a:rPr>
+              <a:t>Parent becomes the enforcer</a:t>
+            </a:r>
+          </a:p>
+          <a:p>
+            <a:pPr indent="-201168" marL="201168">
+              <a:lnSpc>
+                <a:spcPct val="115000"/>
+              </a:lnSpc>
+              <a:spcAft>
+                <a:spcPts val="1000"/>
+              </a:spcAft>
+              <a:buClr>
+                <a:srgbClr val="8A8F8B"/>
+              </a:buClr>
+              <a:buFont typeface="Arial"/>
+              <a:buChar char="✗"/>
+            </a:pPr>
+            <a:r>
+              <a:rPr sz="1450">
+                <a:solidFill>
+                  <a:srgbClr val="5B6A5F"/>
+                </a:solidFill>
+                <a:latin typeface="Calibri"/>
+              </a:rPr>
+              <a:t>One fixed rule for every family</a:t>
+            </a:r>
+          </a:p>
+          <a:p>
+            <a:pPr indent="-201168" marL="201168">
+              <a:lnSpc>
+                <a:spcPct val="115000"/>
+              </a:lnSpc>
+              <a:spcAft>
+                <a:spcPts val="1000"/>
+              </a:spcAft>
+              <a:buClr>
+                <a:srgbClr val="8A8F8B"/>
+              </a:buClr>
+              <a:buFont typeface="Arial"/>
+              <a:buChar char="✗"/>
+            </a:pPr>
+            <a:r>
+              <a:rPr sz="1450">
+                <a:solidFill>
+                  <a:srgbClr val="5B6A5F"/>
+                </a:solidFill>
+                <a:latin typeface="Calibri"/>
+              </a:rPr>
+              <a:t>Screen time becomes a daily fight</a:t>
+            </a:r>
+          </a:p>
+        </p:txBody>
+      </p:sp>
+      <p:sp>
+        <p:nvSpPr>
+          <p:cNvPr id="7" name="Rounded Rectangle 6"/>
           <p:cNvSpPr/>
           <p:nvPr/>
         </p:nvSpPr>
         <p:spPr>
           <a:xfrm>
-            <a:off x="3611879" y="1965960"/>
-            <a:ext cx="1097280" cy="1097280"/>
-          </a:xfrm>
-          <a:prstGeom prst="ellipse">
-            <a:avLst/>
+            <a:off x="6309360" y="1920240"/>
+            <a:ext cx="5074920" cy="4114800"/>
+          </a:xfrm>
+          <a:prstGeom prst="roundRect">
+            <a:avLst>
+              <a:gd name="adj" fmla="val 10000"/>
+            </a:avLst>
           </a:prstGeom>
           <a:solidFill>
-            <a:srgbClr val="F7E1D5"/>
+            <a:srgbClr val="3E7A5C"/>
           </a:solidFill>
           <a:ln>
             <a:noFill/>
@@ -5420,31 +6230,23 @@
           </a:fontRef>
         </p:style>
         <p:txBody>
-          <a:bodyPr rtlCol="0" anchor="ctr" lIns="0" rIns="0" tIns="0" bIns="0" wrap="none"/>
+          <a:bodyPr rtlCol="0" anchor="ctr"/>
           <a:lstStyle/>
           <a:p>
             <a:pPr algn="ctr"/>
-            <a:r>
-              <a:rPr sz="3300">
-                <a:solidFill>
-                  <a:srgbClr val="DD6B42"/>
-                </a:solidFill>
-              </a:rPr>
-              <a:t>🏃</a:t>
-            </a:r>
-          </a:p>
-        </p:txBody>
-      </p:sp>
-      <p:sp>
-        <p:nvSpPr>
-          <p:cNvPr id="7" name="TextBox 6"/>
+          </a:p>
+        </p:txBody>
+      </p:sp>
+      <p:sp>
+        <p:nvSpPr>
+          <p:cNvPr id="8" name="TextBox 7"/>
           <p:cNvSpPr txBox="1"/>
           <p:nvPr/>
         </p:nvSpPr>
         <p:spPr>
           <a:xfrm>
-            <a:off x="3337560" y="3154680"/>
-            <a:ext cx="1645920" cy="365760"/>
+            <a:off x="6583680" y="2148840"/>
+            <a:ext cx="4480560" cy="457200"/>
           </a:xfrm>
           <a:prstGeom prst="rect">
             <a:avLst/>
@@ -5457,71 +6259,19 @@
           </a:bodyPr>
           <a:lstStyle/>
           <a:p>
-            <a:pPr algn="ctr">
+            <a:pPr algn="l">
               <a:lnSpc>
                 <a:spcPct val="115000"/>
               </a:lnSpc>
             </a:pPr>
             <a:r>
-              <a:rPr sz="1400" b="1" i="0">
-                <a:solidFill>
-                  <a:srgbClr val="1F2D22"/>
+              <a:rPr sz="1300" b="1" i="0">
+                <a:solidFill>
+                  <a:srgbClr val="DCE8D9"/>
                 </a:solidFill>
                 <a:latin typeface="Calibri"/>
               </a:rPr>
-              <a:t>Move</a:t>
-            </a:r>
-          </a:p>
-        </p:txBody>
-      </p:sp>
-      <p:sp>
-        <p:nvSpPr>
-          <p:cNvPr id="8" name="Oval 7"/>
-          <p:cNvSpPr/>
-          <p:nvPr/>
-        </p:nvSpPr>
-        <p:spPr>
-          <a:xfrm>
-            <a:off x="5943600" y="1965960"/>
-            <a:ext cx="1097280" cy="1097280"/>
-          </a:xfrm>
-          <a:prstGeom prst="ellipse">
-            <a:avLst/>
-          </a:prstGeom>
-          <a:solidFill>
-            <a:srgbClr val="E2E2F5"/>
-          </a:solidFill>
-          <a:ln>
-            <a:noFill/>
-          </a:ln>
-          <a:effectLst/>
-        </p:spPr>
-        <p:style>
-          <a:lnRef idx="1">
-            <a:schemeClr val="accent1"/>
-          </a:lnRef>
-          <a:fillRef idx="3">
-            <a:schemeClr val="accent1"/>
-          </a:fillRef>
-          <a:effectRef idx="2">
-            <a:schemeClr val="accent1"/>
-          </a:effectRef>
-          <a:fontRef idx="minor">
-            <a:schemeClr val="lt1"/>
-          </a:fontRef>
-        </p:style>
-        <p:txBody>
-          <a:bodyPr rtlCol="0" anchor="ctr" lIns="0" rIns="0" tIns="0" bIns="0" wrap="none"/>
-          <a:lstStyle/>
-          <a:p>
-            <a:pPr algn="ctr"/>
-            <a:r>
-              <a:rPr sz="3300">
-                <a:solidFill>
-                  <a:srgbClr val="6E6FBF"/>
-                </a:solidFill>
-              </a:rPr>
-              <a:t>🌙</a:t>
+              <a:t>HEALTH FIRST</a:t>
             </a:r>
           </a:p>
         </p:txBody>
@@ -5534,8 +6284,8 @@
         </p:nvSpPr>
         <p:spPr>
           <a:xfrm>
-            <a:off x="5669279" y="3154680"/>
-            <a:ext cx="1645920" cy="365760"/>
+            <a:off x="6583680" y="2651760"/>
+            <a:ext cx="4480560" cy="3200400"/>
           </a:xfrm>
           <a:prstGeom prst="rect">
             <a:avLst/>
@@ -5543,657 +6293,128 @@
           <a:noFill/>
         </p:spPr>
         <p:txBody>
-          <a:bodyPr wrap="square" anchor="t" lIns="0" rIns="0" tIns="0" bIns="0">
+          <a:bodyPr wrap="square" lIns="0" rIns="0" tIns="0" bIns="0">
             <a:spAutoFit/>
           </a:bodyPr>
           <a:lstStyle/>
           <a:p>
-            <a:pPr algn="ctr">
+            <a:pPr indent="-201168" marL="201168">
               <a:lnSpc>
                 <a:spcPct val="115000"/>
               </a:lnSpc>
+              <a:spcAft>
+                <a:spcPts val="1000"/>
+              </a:spcAft>
+              <a:buClr>
+                <a:srgbClr val="FFFFFF"/>
+              </a:buClr>
+              <a:buFont typeface="Arial"/>
+              <a:buChar char="✓"/>
             </a:pPr>
             <a:r>
-              <a:rPr sz="1400" b="1" i="0">
-                <a:solidFill>
-                  <a:srgbClr val="1F2D22"/>
+              <a:rPr sz="1450">
+                <a:solidFill>
+                  <a:srgbClr val="FFFFFF"/>
                 </a:solidFill>
                 <a:latin typeface="Calibri"/>
               </a:rPr>
-              <a:t>Sleep</a:t>
-            </a:r>
-          </a:p>
-        </p:txBody>
-      </p:sp>
-      <p:sp>
-        <p:nvSpPr>
-          <p:cNvPr id="10" name="Oval 9"/>
-          <p:cNvSpPr/>
-          <p:nvPr/>
-        </p:nvSpPr>
-        <p:spPr>
-          <a:xfrm>
-            <a:off x="8275320" y="1965960"/>
-            <a:ext cx="1097280" cy="1097280"/>
-          </a:xfrm>
-          <a:prstGeom prst="ellipse">
-            <a:avLst/>
-          </a:prstGeom>
-          <a:solidFill>
-            <a:srgbClr val="F7E1D5"/>
-          </a:solidFill>
-          <a:ln>
-            <a:noFill/>
-          </a:ln>
-          <a:effectLst/>
-        </p:spPr>
-        <p:style>
-          <a:lnRef idx="1">
-            <a:schemeClr val="accent1"/>
-          </a:lnRef>
-          <a:fillRef idx="3">
-            <a:schemeClr val="accent1"/>
-          </a:fillRef>
-          <a:effectRef idx="2">
-            <a:schemeClr val="accent1"/>
-          </a:effectRef>
-          <a:fontRef idx="minor">
-            <a:schemeClr val="lt1"/>
-          </a:fontRef>
-        </p:style>
-        <p:txBody>
-          <a:bodyPr rtlCol="0" anchor="ctr" lIns="0" rIns="0" tIns="0" bIns="0" wrap="none"/>
-          <a:lstStyle/>
-          <a:p>
-            <a:pPr algn="ctr"/>
-            <a:r>
-              <a:rPr sz="3300">
-                <a:solidFill>
-                  <a:srgbClr val="DD6B42"/>
-                </a:solidFill>
-              </a:rPr>
-              <a:t>🍎</a:t>
-            </a:r>
-          </a:p>
-        </p:txBody>
-      </p:sp>
-      <p:sp>
-        <p:nvSpPr>
-          <p:cNvPr id="11" name="TextBox 10"/>
-          <p:cNvSpPr txBox="1"/>
-          <p:nvPr/>
-        </p:nvSpPr>
-        <p:spPr>
-          <a:xfrm>
-            <a:off x="8001000" y="3154680"/>
-            <a:ext cx="1645920" cy="365760"/>
-          </a:xfrm>
-          <a:prstGeom prst="rect">
-            <a:avLst/>
-          </a:prstGeom>
-          <a:noFill/>
-        </p:spPr>
-        <p:txBody>
-          <a:bodyPr wrap="square" anchor="t" lIns="0" rIns="0" tIns="0" bIns="0">
-            <a:spAutoFit/>
-          </a:bodyPr>
-          <a:lstStyle/>
-          <a:p>
-            <a:pPr algn="ctr">
+              <a:t>Rewards healthy habits with earned time</a:t>
+            </a:r>
+          </a:p>
+          <a:p>
+            <a:pPr indent="-201168" marL="201168">
               <a:lnSpc>
                 <a:spcPct val="115000"/>
               </a:lnSpc>
+              <a:spcAft>
+                <a:spcPts val="1000"/>
+              </a:spcAft>
+              <a:buClr>
+                <a:srgbClr val="FFFFFF"/>
+              </a:buClr>
+              <a:buFont typeface="Arial"/>
+              <a:buChar char="✓"/>
             </a:pPr>
             <a:r>
-              <a:rPr sz="1400" b="1" i="0">
-                <a:solidFill>
-                  <a:srgbClr val="1F2D22"/>
+              <a:rPr sz="1450">
+                <a:solidFill>
+                  <a:srgbClr val="FFFFFF"/>
                 </a:solidFill>
                 <a:latin typeface="Calibri"/>
               </a:rPr>
-              <a:t>Fruit</a:t>
-            </a:r>
-          </a:p>
-        </p:txBody>
-      </p:sp>
-      <p:sp>
-        <p:nvSpPr>
-          <p:cNvPr id="12" name="Rounded Rectangle 11"/>
-          <p:cNvSpPr/>
-          <p:nvPr/>
-        </p:nvSpPr>
-        <p:spPr>
-          <a:xfrm>
-            <a:off x="914400" y="3886200"/>
-            <a:ext cx="1554480" cy="594360"/>
-          </a:xfrm>
-          <a:prstGeom prst="roundRect">
-            <a:avLst>
-              <a:gd name="adj" fmla="val 10000"/>
-            </a:avLst>
-          </a:prstGeom>
-          <a:solidFill>
-            <a:srgbClr val="DCE8D9"/>
-          </a:solidFill>
-          <a:ln>
-            <a:noFill/>
-          </a:ln>
-          <a:effectLst/>
-        </p:spPr>
-        <p:style>
-          <a:lnRef idx="1">
-            <a:schemeClr val="accent1"/>
-          </a:lnRef>
-          <a:fillRef idx="3">
-            <a:schemeClr val="accent1"/>
-          </a:fillRef>
-          <a:effectRef idx="2">
-            <a:schemeClr val="accent1"/>
-          </a:effectRef>
-          <a:fontRef idx="minor">
-            <a:schemeClr val="lt1"/>
-          </a:fontRef>
-        </p:style>
-        <p:txBody>
-          <a:bodyPr rtlCol="0" anchor="ctr"/>
-          <a:lstStyle/>
-          <a:p>
-            <a:pPr algn="ctr"/>
-          </a:p>
-        </p:txBody>
-      </p:sp>
-      <p:sp>
-        <p:nvSpPr>
-          <p:cNvPr id="13" name="TextBox 12"/>
-          <p:cNvSpPr txBox="1"/>
-          <p:nvPr/>
-        </p:nvSpPr>
-        <p:spPr>
-          <a:xfrm>
-            <a:off x="914400" y="3886200"/>
-            <a:ext cx="1554480" cy="594360"/>
-          </a:xfrm>
-          <a:prstGeom prst="rect">
-            <a:avLst/>
-          </a:prstGeom>
-          <a:noFill/>
-        </p:spPr>
-        <p:txBody>
-          <a:bodyPr wrap="square" anchor="ctr" lIns="0" rIns="0" tIns="0" bIns="0">
-            <a:spAutoFit/>
-          </a:bodyPr>
-          <a:lstStyle/>
-          <a:p>
-            <a:pPr algn="ctr">
+              <a:t>Kid feels motivated by immediate credit</a:t>
+            </a:r>
+          </a:p>
+          <a:p>
+            <a:pPr indent="-201168" marL="201168">
               <a:lnSpc>
                 <a:spcPct val="115000"/>
               </a:lnSpc>
+              <a:spcAft>
+                <a:spcPts val="1000"/>
+              </a:spcAft>
+              <a:buClr>
+                <a:srgbClr val="FFFFFF"/>
+              </a:buClr>
+              <a:buFont typeface="Arial"/>
+              <a:buChar char="✓"/>
             </a:pPr>
             <a:r>
-              <a:rPr sz="1300" b="1" i="0">
-                <a:solidFill>
-                  <a:srgbClr val="2C5A44"/>
+              <a:rPr sz="1450">
+                <a:solidFill>
+                  <a:srgbClr val="FFFFFF"/>
                 </a:solidFill>
                 <a:latin typeface="Calibri"/>
               </a:rPr>
-              <a:t>Checklist</a:t>
-            </a:r>
-          </a:p>
-        </p:txBody>
-      </p:sp>
-      <p:sp>
-        <p:nvSpPr>
-          <p:cNvPr id="14" name="TextBox 13"/>
-          <p:cNvSpPr txBox="1"/>
-          <p:nvPr/>
-        </p:nvSpPr>
-        <p:spPr>
-          <a:xfrm>
-            <a:off x="2468880" y="3977639"/>
-            <a:ext cx="457200" cy="457200"/>
-          </a:xfrm>
-          <a:prstGeom prst="rect">
-            <a:avLst/>
-          </a:prstGeom>
-          <a:noFill/>
-        </p:spPr>
-        <p:txBody>
-          <a:bodyPr wrap="square" anchor="t" lIns="0" rIns="0" tIns="0" bIns="0">
-            <a:spAutoFit/>
-          </a:bodyPr>
-          <a:lstStyle/>
-          <a:p>
-            <a:pPr algn="ctr">
+              <a:t>Parent becomes a coach, not a warden</a:t>
+            </a:r>
+          </a:p>
+          <a:p>
+            <a:pPr indent="-201168" marL="201168">
               <a:lnSpc>
                 <a:spcPct val="115000"/>
               </a:lnSpc>
+              <a:spcAft>
+                <a:spcPts val="1000"/>
+              </a:spcAft>
+              <a:buClr>
+                <a:srgbClr val="FFFFFF"/>
+              </a:buClr>
+              <a:buFont typeface="Arial"/>
+              <a:buChar char="✓"/>
             </a:pPr>
             <a:r>
-              <a:rPr sz="2000" b="1" i="0">
-                <a:solidFill>
-                  <a:srgbClr val="DD6B42"/>
+              <a:rPr sz="1450">
+                <a:solidFill>
+                  <a:srgbClr val="FFFFFF"/>
                 </a:solidFill>
                 <a:latin typeface="Calibri"/>
               </a:rPr>
-              <a:t>→</a:t>
-            </a:r>
-          </a:p>
-        </p:txBody>
-      </p:sp>
-      <p:sp>
-        <p:nvSpPr>
-          <p:cNvPr id="15" name="Rounded Rectangle 14"/>
-          <p:cNvSpPr/>
-          <p:nvPr/>
-        </p:nvSpPr>
-        <p:spPr>
-          <a:xfrm>
-            <a:off x="2926080" y="3886200"/>
-            <a:ext cx="2286000" cy="594360"/>
-          </a:xfrm>
-          <a:prstGeom prst="roundRect">
-            <a:avLst>
-              <a:gd name="adj" fmla="val 10000"/>
-            </a:avLst>
-          </a:prstGeom>
-          <a:solidFill>
-            <a:srgbClr val="DCE8D9"/>
-          </a:solidFill>
-          <a:ln>
-            <a:noFill/>
-          </a:ln>
-          <a:effectLst/>
-        </p:spPr>
-        <p:style>
-          <a:lnRef idx="1">
-            <a:schemeClr val="accent1"/>
-          </a:lnRef>
-          <a:fillRef idx="3">
-            <a:schemeClr val="accent1"/>
-          </a:fillRef>
-          <a:effectRef idx="2">
-            <a:schemeClr val="accent1"/>
-          </a:effectRef>
-          <a:fontRef idx="minor">
-            <a:schemeClr val="lt1"/>
-          </a:fontRef>
-        </p:style>
-        <p:txBody>
-          <a:bodyPr rtlCol="0" anchor="ctr"/>
-          <a:lstStyle/>
-          <a:p>
-            <a:pPr algn="ctr"/>
-          </a:p>
-        </p:txBody>
-      </p:sp>
-      <p:sp>
-        <p:nvSpPr>
-          <p:cNvPr id="16" name="TextBox 15"/>
-          <p:cNvSpPr txBox="1"/>
-          <p:nvPr/>
-        </p:nvSpPr>
-        <p:spPr>
-          <a:xfrm>
-            <a:off x="2926080" y="3886200"/>
-            <a:ext cx="2286000" cy="594360"/>
-          </a:xfrm>
-          <a:prstGeom prst="rect">
-            <a:avLst/>
-          </a:prstGeom>
-          <a:noFill/>
-        </p:spPr>
-        <p:txBody>
-          <a:bodyPr wrap="square" anchor="ctr" lIns="0" rIns="0" tIns="0" bIns="0">
-            <a:spAutoFit/>
-          </a:bodyPr>
-          <a:lstStyle/>
-          <a:p>
-            <a:pPr algn="ctr">
+              <a:t>Every goal and reward is configurable</a:t>
+            </a:r>
+          </a:p>
+          <a:p>
+            <a:pPr indent="-201168" marL="201168">
               <a:lnSpc>
                 <a:spcPct val="115000"/>
               </a:lnSpc>
+              <a:spcAft>
+                <a:spcPts val="1000"/>
+              </a:spcAft>
+              <a:buClr>
+                <a:srgbClr val="FFFFFF"/>
+              </a:buClr>
+              <a:buFont typeface="Arial"/>
+              <a:buChar char="✓"/>
             </a:pPr>
             <a:r>
-              <a:rPr sz="1300" b="1" i="0">
-                <a:solidFill>
-                  <a:srgbClr val="2C5A44"/>
+              <a:rPr sz="1450">
+                <a:solidFill>
+                  <a:srgbClr val="FFFFFF"/>
                 </a:solidFill>
                 <a:latin typeface="Calibri"/>
               </a:rPr>
-              <a:t>Photo or PIN Proof</a:t>
-            </a:r>
-          </a:p>
-        </p:txBody>
-      </p:sp>
-      <p:sp>
-        <p:nvSpPr>
-          <p:cNvPr id="17" name="TextBox 16"/>
-          <p:cNvSpPr txBox="1"/>
-          <p:nvPr/>
-        </p:nvSpPr>
-        <p:spPr>
-          <a:xfrm>
-            <a:off x="5212080" y="3977639"/>
-            <a:ext cx="457200" cy="457200"/>
-          </a:xfrm>
-          <a:prstGeom prst="rect">
-            <a:avLst/>
-          </a:prstGeom>
-          <a:noFill/>
-        </p:spPr>
-        <p:txBody>
-          <a:bodyPr wrap="square" anchor="t" lIns="0" rIns="0" tIns="0" bIns="0">
-            <a:spAutoFit/>
-          </a:bodyPr>
-          <a:lstStyle/>
-          <a:p>
-            <a:pPr algn="ctr">
-              <a:lnSpc>
-                <a:spcPct val="115000"/>
-              </a:lnSpc>
-            </a:pPr>
-            <a:r>
-              <a:rPr sz="2000" b="1" i="0">
-                <a:solidFill>
-                  <a:srgbClr val="DD6B42"/>
-                </a:solidFill>
-                <a:latin typeface="Calibri"/>
-              </a:rPr>
-              <a:t>→</a:t>
-            </a:r>
-          </a:p>
-        </p:txBody>
-      </p:sp>
-      <p:sp>
-        <p:nvSpPr>
-          <p:cNvPr id="18" name="Rounded Rectangle 17"/>
-          <p:cNvSpPr/>
-          <p:nvPr/>
-        </p:nvSpPr>
-        <p:spPr>
-          <a:xfrm>
-            <a:off x="5669280" y="3886200"/>
-            <a:ext cx="2103120" cy="594360"/>
-          </a:xfrm>
-          <a:prstGeom prst="roundRect">
-            <a:avLst>
-              <a:gd name="adj" fmla="val 10000"/>
-            </a:avLst>
-          </a:prstGeom>
-          <a:solidFill>
-            <a:srgbClr val="DCE8D9"/>
-          </a:solidFill>
-          <a:ln>
-            <a:noFill/>
-          </a:ln>
-          <a:effectLst/>
-        </p:spPr>
-        <p:style>
-          <a:lnRef idx="1">
-            <a:schemeClr val="accent1"/>
-          </a:lnRef>
-          <a:fillRef idx="3">
-            <a:schemeClr val="accent1"/>
-          </a:fillRef>
-          <a:effectRef idx="2">
-            <a:schemeClr val="accent1"/>
-          </a:effectRef>
-          <a:fontRef idx="minor">
-            <a:schemeClr val="lt1"/>
-          </a:fontRef>
-        </p:style>
-        <p:txBody>
-          <a:bodyPr rtlCol="0" anchor="ctr"/>
-          <a:lstStyle/>
-          <a:p>
-            <a:pPr algn="ctr"/>
-          </a:p>
-        </p:txBody>
-      </p:sp>
-      <p:sp>
-        <p:nvSpPr>
-          <p:cNvPr id="19" name="TextBox 18"/>
-          <p:cNvSpPr txBox="1"/>
-          <p:nvPr/>
-        </p:nvSpPr>
-        <p:spPr>
-          <a:xfrm>
-            <a:off x="5669280" y="3886200"/>
-            <a:ext cx="2103120" cy="594360"/>
-          </a:xfrm>
-          <a:prstGeom prst="rect">
-            <a:avLst/>
-          </a:prstGeom>
-          <a:noFill/>
-        </p:spPr>
-        <p:txBody>
-          <a:bodyPr wrap="square" anchor="ctr" lIns="0" rIns="0" tIns="0" bIns="0">
-            <a:spAutoFit/>
-          </a:bodyPr>
-          <a:lstStyle/>
-          <a:p>
-            <a:pPr algn="ctr">
-              <a:lnSpc>
-                <a:spcPct val="115000"/>
-              </a:lnSpc>
-            </a:pPr>
-            <a:r>
-              <a:rPr sz="1300" b="1" i="0">
-                <a:solidFill>
-                  <a:srgbClr val="2C5A44"/>
-                </a:solidFill>
-                <a:latin typeface="Calibri"/>
-              </a:rPr>
-              <a:t>Minutes Banked</a:t>
-            </a:r>
-          </a:p>
-        </p:txBody>
-      </p:sp>
-      <p:sp>
-        <p:nvSpPr>
-          <p:cNvPr id="20" name="TextBox 19"/>
-          <p:cNvSpPr txBox="1"/>
-          <p:nvPr/>
-        </p:nvSpPr>
-        <p:spPr>
-          <a:xfrm>
-            <a:off x="7772400" y="3977639"/>
-            <a:ext cx="457200" cy="457200"/>
-          </a:xfrm>
-          <a:prstGeom prst="rect">
-            <a:avLst/>
-          </a:prstGeom>
-          <a:noFill/>
-        </p:spPr>
-        <p:txBody>
-          <a:bodyPr wrap="square" anchor="t" lIns="0" rIns="0" tIns="0" bIns="0">
-            <a:spAutoFit/>
-          </a:bodyPr>
-          <a:lstStyle/>
-          <a:p>
-            <a:pPr algn="ctr">
-              <a:lnSpc>
-                <a:spcPct val="115000"/>
-              </a:lnSpc>
-            </a:pPr>
-            <a:r>
-              <a:rPr sz="2000" b="1" i="0">
-                <a:solidFill>
-                  <a:srgbClr val="DD6B42"/>
-                </a:solidFill>
-                <a:latin typeface="Calibri"/>
-              </a:rPr>
-              <a:t>→</a:t>
-            </a:r>
-          </a:p>
-        </p:txBody>
-      </p:sp>
-      <p:sp>
-        <p:nvSpPr>
-          <p:cNvPr id="21" name="Rounded Rectangle 20"/>
-          <p:cNvSpPr/>
-          <p:nvPr/>
-        </p:nvSpPr>
-        <p:spPr>
-          <a:xfrm>
-            <a:off x="8229600" y="3886200"/>
-            <a:ext cx="1554480" cy="594360"/>
-          </a:xfrm>
-          <a:prstGeom prst="roundRect">
-            <a:avLst>
-              <a:gd name="adj" fmla="val 10000"/>
-            </a:avLst>
-          </a:prstGeom>
-          <a:solidFill>
-            <a:srgbClr val="DCE8D9"/>
-          </a:solidFill>
-          <a:ln>
-            <a:noFill/>
-          </a:ln>
-          <a:effectLst/>
-        </p:spPr>
-        <p:style>
-          <a:lnRef idx="1">
-            <a:schemeClr val="accent1"/>
-          </a:lnRef>
-          <a:fillRef idx="3">
-            <a:schemeClr val="accent1"/>
-          </a:fillRef>
-          <a:effectRef idx="2">
-            <a:schemeClr val="accent1"/>
-          </a:effectRef>
-          <a:fontRef idx="minor">
-            <a:schemeClr val="lt1"/>
-          </a:fontRef>
-        </p:style>
-        <p:txBody>
-          <a:bodyPr rtlCol="0" anchor="ctr"/>
-          <a:lstStyle/>
-          <a:p>
-            <a:pPr algn="ctr"/>
-          </a:p>
-        </p:txBody>
-      </p:sp>
-      <p:sp>
-        <p:nvSpPr>
-          <p:cNvPr id="22" name="TextBox 21"/>
-          <p:cNvSpPr txBox="1"/>
-          <p:nvPr/>
-        </p:nvSpPr>
-        <p:spPr>
-          <a:xfrm>
-            <a:off x="8229600" y="3886200"/>
-            <a:ext cx="1554480" cy="594360"/>
-          </a:xfrm>
-          <a:prstGeom prst="rect">
-            <a:avLst/>
-          </a:prstGeom>
-          <a:noFill/>
-        </p:spPr>
-        <p:txBody>
-          <a:bodyPr wrap="square" anchor="ctr" lIns="0" rIns="0" tIns="0" bIns="0">
-            <a:spAutoFit/>
-          </a:bodyPr>
-          <a:lstStyle/>
-          <a:p>
-            <a:pPr algn="ctr">
-              <a:lnSpc>
-                <a:spcPct val="115000"/>
-              </a:lnSpc>
-            </a:pPr>
-            <a:r>
-              <a:rPr sz="1300" b="1" i="0">
-                <a:solidFill>
-                  <a:srgbClr val="2C5A44"/>
-                </a:solidFill>
-                <a:latin typeface="Calibri"/>
-              </a:rPr>
-              <a:t>Unlock</a:t>
-            </a:r>
-          </a:p>
-        </p:txBody>
-      </p:sp>
-      <p:sp>
-        <p:nvSpPr>
-          <p:cNvPr id="23" name="Rounded Rectangle 22"/>
-          <p:cNvSpPr/>
-          <p:nvPr/>
-        </p:nvSpPr>
-        <p:spPr>
-          <a:xfrm>
-            <a:off x="822960" y="4846320"/>
-            <a:ext cx="10515600" cy="1371600"/>
-          </a:xfrm>
-          <a:prstGeom prst="roundRect">
-            <a:avLst>
-              <a:gd name="adj" fmla="val 10000"/>
-            </a:avLst>
-          </a:prstGeom>
-          <a:solidFill>
-            <a:srgbClr val="F5E7C9"/>
-          </a:solidFill>
-          <a:ln>
-            <a:noFill/>
-          </a:ln>
-          <a:effectLst/>
-        </p:spPr>
-        <p:style>
-          <a:lnRef idx="1">
-            <a:schemeClr val="accent1"/>
-          </a:lnRef>
-          <a:fillRef idx="3">
-            <a:schemeClr val="accent1"/>
-          </a:fillRef>
-          <a:effectRef idx="2">
-            <a:schemeClr val="accent1"/>
-          </a:effectRef>
-          <a:fontRef idx="minor">
-            <a:schemeClr val="lt1"/>
-          </a:fontRef>
-        </p:style>
-        <p:txBody>
-          <a:bodyPr rtlCol="0" anchor="ctr"/>
-          <a:lstStyle/>
-          <a:p>
-            <a:pPr algn="ctr"/>
-          </a:p>
-        </p:txBody>
-      </p:sp>
-      <p:sp>
-        <p:nvSpPr>
-          <p:cNvPr id="24" name="TextBox 23"/>
-          <p:cNvSpPr txBox="1"/>
-          <p:nvPr/>
-        </p:nvSpPr>
-        <p:spPr>
-          <a:xfrm>
-            <a:off x="1188720" y="5074920"/>
-            <a:ext cx="9784080" cy="914400"/>
-          </a:xfrm>
-          <a:prstGeom prst="rect">
-            <a:avLst/>
-          </a:prstGeom>
-          <a:noFill/>
-        </p:spPr>
-        <p:txBody>
-          <a:bodyPr wrap="square" anchor="ctr" lIns="0" rIns="0" tIns="0" bIns="0">
-            <a:spAutoFit/>
-          </a:bodyPr>
-          <a:lstStyle/>
-          <a:p>
-            <a:pPr algn="l">
-              <a:lnSpc>
-                <a:spcPct val="125000"/>
-              </a:lnSpc>
-            </a:pPr>
-            <a:r>
-              <a:rPr sz="1350" b="0" i="0">
-                <a:solidFill>
-                  <a:srgbClr val="2C5A44"/>
-                </a:solidFill>
-                <a:latin typeface="Calibri"/>
-              </a:rPr>
-              <a:t>The one exception: Sleep is checked each morning about last night's bedtime, not at night — a real bug we caught and fixed, so the reward is never gated on something unverifiable until after bedtime.</a:t>
+              <a:t>Screen time becomes a shared goal</a:t>
             </a:r>
           </a:p>
         </p:txBody>
@@ -6207,6 +6428,1016 @@
 </file>
 
 <file path=ppt/slides/slide5.xml><?xml version="1.0" encoding="utf-8"?>
+<p:sld xmlns:a="http://schemas.openxmlformats.org/drawingml/2006/main" xmlns:p="http://schemas.openxmlformats.org/presentationml/2006/main" xmlns:r="http://schemas.openxmlformats.org/officeDocument/2006/relationships">
+  <p:cSld>
+    <p:bg>
+      <p:bgPr>
+        <a:solidFill>
+          <a:srgbClr val="FFFFFF"/>
+        </a:solidFill>
+        <a:effectLst/>
+      </p:bgPr>
+    </p:bg>
+    <p:spTree>
+      <p:nvGrpSpPr>
+        <p:cNvPr id="1" name=""/>
+        <p:cNvGrpSpPr/>
+        <p:nvPr/>
+      </p:nvGrpSpPr>
+      <p:grpSpPr/>
+      <p:sp>
+        <p:nvSpPr>
+          <p:cNvPr id="2" name="TextBox 1"/>
+          <p:cNvSpPr txBox="1"/>
+          <p:nvPr/>
+        </p:nvSpPr>
+        <p:spPr>
+          <a:xfrm>
+            <a:off x="822960" y="502920"/>
+            <a:ext cx="7315200" cy="548640"/>
+          </a:xfrm>
+          <a:prstGeom prst="rect">
+            <a:avLst/>
+          </a:prstGeom>
+          <a:noFill/>
+        </p:spPr>
+        <p:txBody>
+          <a:bodyPr wrap="square" anchor="t" lIns="0" rIns="0" tIns="0" bIns="0">
+            <a:spAutoFit/>
+          </a:bodyPr>
+          <a:lstStyle/>
+          <a:p>
+            <a:pPr algn="l">
+              <a:lnSpc>
+                <a:spcPct val="115000"/>
+              </a:lnSpc>
+            </a:pPr>
+            <a:r>
+              <a:rPr sz="3000" b="1" i="0">
+                <a:solidFill>
+                  <a:srgbClr val="1F2D22"/>
+                </a:solidFill>
+                <a:latin typeface="Cambria"/>
+              </a:rPr>
+              <a:t>How It Works</a:t>
+            </a:r>
+          </a:p>
+        </p:txBody>
+      </p:sp>
+      <p:sp>
+        <p:nvSpPr>
+          <p:cNvPr id="3" name="TextBox 2"/>
+          <p:cNvSpPr txBox="1"/>
+          <p:nvPr/>
+        </p:nvSpPr>
+        <p:spPr>
+          <a:xfrm>
+            <a:off x="822960" y="1143000"/>
+            <a:ext cx="9601200" cy="548640"/>
+          </a:xfrm>
+          <a:prstGeom prst="rect">
+            <a:avLst/>
+          </a:prstGeom>
+          <a:noFill/>
+        </p:spPr>
+        <p:txBody>
+          <a:bodyPr wrap="square" anchor="t" lIns="0" rIns="0" tIns="0" bIns="0">
+            <a:spAutoFit/>
+          </a:bodyPr>
+          <a:lstStyle/>
+          <a:p>
+            <a:pPr algn="l">
+              <a:lnSpc>
+                <a:spcPct val="115000"/>
+              </a:lnSpc>
+            </a:pPr>
+            <a:r>
+              <a:rPr sz="1500" b="0" i="0">
+                <a:solidFill>
+                  <a:srgbClr val="5B6A5F"/>
+                </a:solidFill>
+                <a:latin typeface="Calibri"/>
+              </a:rPr>
+              <a:t>A daily checklist of health goals — proven honestly — banks screen time.</a:t>
+            </a:r>
+          </a:p>
+        </p:txBody>
+      </p:sp>
+      <p:sp>
+        <p:nvSpPr>
+          <p:cNvPr id="4" name="Oval 3"/>
+          <p:cNvSpPr/>
+          <p:nvPr/>
+        </p:nvSpPr>
+        <p:spPr>
+          <a:xfrm>
+            <a:off x="1280160" y="1965960"/>
+            <a:ext cx="1097280" cy="1097280"/>
+          </a:xfrm>
+          <a:prstGeom prst="ellipse">
+            <a:avLst/>
+          </a:prstGeom>
+          <a:solidFill>
+            <a:srgbClr val="DCE8D9"/>
+          </a:solidFill>
+          <a:ln>
+            <a:noFill/>
+          </a:ln>
+          <a:effectLst/>
+        </p:spPr>
+        <p:style>
+          <a:lnRef idx="1">
+            <a:schemeClr val="accent1"/>
+          </a:lnRef>
+          <a:fillRef idx="3">
+            <a:schemeClr val="accent1"/>
+          </a:fillRef>
+          <a:effectRef idx="2">
+            <a:schemeClr val="accent1"/>
+          </a:effectRef>
+          <a:fontRef idx="minor">
+            <a:schemeClr val="lt1"/>
+          </a:fontRef>
+        </p:style>
+        <p:txBody>
+          <a:bodyPr rtlCol="0" anchor="ctr" lIns="0" rIns="0" tIns="0" bIns="0" wrap="none"/>
+          <a:lstStyle/>
+          <a:p>
+            <a:pPr algn="ctr"/>
+            <a:r>
+              <a:rPr sz="3300">
+                <a:solidFill>
+                  <a:srgbClr val="3E7A5C"/>
+                </a:solidFill>
+              </a:rPr>
+              <a:t>💧</a:t>
+            </a:r>
+          </a:p>
+        </p:txBody>
+      </p:sp>
+      <p:sp>
+        <p:nvSpPr>
+          <p:cNvPr id="5" name="TextBox 4"/>
+          <p:cNvSpPr txBox="1"/>
+          <p:nvPr/>
+        </p:nvSpPr>
+        <p:spPr>
+          <a:xfrm>
+            <a:off x="1005840" y="3154680"/>
+            <a:ext cx="1645920" cy="365760"/>
+          </a:xfrm>
+          <a:prstGeom prst="rect">
+            <a:avLst/>
+          </a:prstGeom>
+          <a:noFill/>
+        </p:spPr>
+        <p:txBody>
+          <a:bodyPr wrap="square" anchor="t" lIns="0" rIns="0" tIns="0" bIns="0">
+            <a:spAutoFit/>
+          </a:bodyPr>
+          <a:lstStyle/>
+          <a:p>
+            <a:pPr algn="ctr">
+              <a:lnSpc>
+                <a:spcPct val="115000"/>
+              </a:lnSpc>
+            </a:pPr>
+            <a:r>
+              <a:rPr sz="1400" b="1" i="0">
+                <a:solidFill>
+                  <a:srgbClr val="1F2D22"/>
+                </a:solidFill>
+                <a:latin typeface="Calibri"/>
+              </a:rPr>
+              <a:t>Water</a:t>
+            </a:r>
+          </a:p>
+        </p:txBody>
+      </p:sp>
+      <p:sp>
+        <p:nvSpPr>
+          <p:cNvPr id="6" name="Oval 5"/>
+          <p:cNvSpPr/>
+          <p:nvPr/>
+        </p:nvSpPr>
+        <p:spPr>
+          <a:xfrm>
+            <a:off x="3611879" y="1965960"/>
+            <a:ext cx="1097280" cy="1097280"/>
+          </a:xfrm>
+          <a:prstGeom prst="ellipse">
+            <a:avLst/>
+          </a:prstGeom>
+          <a:solidFill>
+            <a:srgbClr val="F7E1D5"/>
+          </a:solidFill>
+          <a:ln>
+            <a:noFill/>
+          </a:ln>
+          <a:effectLst/>
+        </p:spPr>
+        <p:style>
+          <a:lnRef idx="1">
+            <a:schemeClr val="accent1"/>
+          </a:lnRef>
+          <a:fillRef idx="3">
+            <a:schemeClr val="accent1"/>
+          </a:fillRef>
+          <a:effectRef idx="2">
+            <a:schemeClr val="accent1"/>
+          </a:effectRef>
+          <a:fontRef idx="minor">
+            <a:schemeClr val="lt1"/>
+          </a:fontRef>
+        </p:style>
+        <p:txBody>
+          <a:bodyPr rtlCol="0" anchor="ctr" lIns="0" rIns="0" tIns="0" bIns="0" wrap="none"/>
+          <a:lstStyle/>
+          <a:p>
+            <a:pPr algn="ctr"/>
+            <a:r>
+              <a:rPr sz="3300">
+                <a:solidFill>
+                  <a:srgbClr val="DD6B42"/>
+                </a:solidFill>
+              </a:rPr>
+              <a:t>🏃</a:t>
+            </a:r>
+          </a:p>
+        </p:txBody>
+      </p:sp>
+      <p:sp>
+        <p:nvSpPr>
+          <p:cNvPr id="7" name="TextBox 6"/>
+          <p:cNvSpPr txBox="1"/>
+          <p:nvPr/>
+        </p:nvSpPr>
+        <p:spPr>
+          <a:xfrm>
+            <a:off x="3337560" y="3154680"/>
+            <a:ext cx="1645920" cy="365760"/>
+          </a:xfrm>
+          <a:prstGeom prst="rect">
+            <a:avLst/>
+          </a:prstGeom>
+          <a:noFill/>
+        </p:spPr>
+        <p:txBody>
+          <a:bodyPr wrap="square" anchor="t" lIns="0" rIns="0" tIns="0" bIns="0">
+            <a:spAutoFit/>
+          </a:bodyPr>
+          <a:lstStyle/>
+          <a:p>
+            <a:pPr algn="ctr">
+              <a:lnSpc>
+                <a:spcPct val="115000"/>
+              </a:lnSpc>
+            </a:pPr>
+            <a:r>
+              <a:rPr sz="1400" b="1" i="0">
+                <a:solidFill>
+                  <a:srgbClr val="1F2D22"/>
+                </a:solidFill>
+                <a:latin typeface="Calibri"/>
+              </a:rPr>
+              <a:t>Move</a:t>
+            </a:r>
+          </a:p>
+        </p:txBody>
+      </p:sp>
+      <p:sp>
+        <p:nvSpPr>
+          <p:cNvPr id="8" name="Oval 7"/>
+          <p:cNvSpPr/>
+          <p:nvPr/>
+        </p:nvSpPr>
+        <p:spPr>
+          <a:xfrm>
+            <a:off x="5943600" y="1965960"/>
+            <a:ext cx="1097280" cy="1097280"/>
+          </a:xfrm>
+          <a:prstGeom prst="ellipse">
+            <a:avLst/>
+          </a:prstGeom>
+          <a:solidFill>
+            <a:srgbClr val="E2E2F5"/>
+          </a:solidFill>
+          <a:ln>
+            <a:noFill/>
+          </a:ln>
+          <a:effectLst/>
+        </p:spPr>
+        <p:style>
+          <a:lnRef idx="1">
+            <a:schemeClr val="accent1"/>
+          </a:lnRef>
+          <a:fillRef idx="3">
+            <a:schemeClr val="accent1"/>
+          </a:fillRef>
+          <a:effectRef idx="2">
+            <a:schemeClr val="accent1"/>
+          </a:effectRef>
+          <a:fontRef idx="minor">
+            <a:schemeClr val="lt1"/>
+          </a:fontRef>
+        </p:style>
+        <p:txBody>
+          <a:bodyPr rtlCol="0" anchor="ctr" lIns="0" rIns="0" tIns="0" bIns="0" wrap="none"/>
+          <a:lstStyle/>
+          <a:p>
+            <a:pPr algn="ctr"/>
+            <a:r>
+              <a:rPr sz="3300">
+                <a:solidFill>
+                  <a:srgbClr val="6E6FBF"/>
+                </a:solidFill>
+              </a:rPr>
+              <a:t>🌙</a:t>
+            </a:r>
+          </a:p>
+        </p:txBody>
+      </p:sp>
+      <p:sp>
+        <p:nvSpPr>
+          <p:cNvPr id="9" name="TextBox 8"/>
+          <p:cNvSpPr txBox="1"/>
+          <p:nvPr/>
+        </p:nvSpPr>
+        <p:spPr>
+          <a:xfrm>
+            <a:off x="5669279" y="3154680"/>
+            <a:ext cx="1645920" cy="365760"/>
+          </a:xfrm>
+          <a:prstGeom prst="rect">
+            <a:avLst/>
+          </a:prstGeom>
+          <a:noFill/>
+        </p:spPr>
+        <p:txBody>
+          <a:bodyPr wrap="square" anchor="t" lIns="0" rIns="0" tIns="0" bIns="0">
+            <a:spAutoFit/>
+          </a:bodyPr>
+          <a:lstStyle/>
+          <a:p>
+            <a:pPr algn="ctr">
+              <a:lnSpc>
+                <a:spcPct val="115000"/>
+              </a:lnSpc>
+            </a:pPr>
+            <a:r>
+              <a:rPr sz="1400" b="1" i="0">
+                <a:solidFill>
+                  <a:srgbClr val="1F2D22"/>
+                </a:solidFill>
+                <a:latin typeface="Calibri"/>
+              </a:rPr>
+              <a:t>Sleep</a:t>
+            </a:r>
+          </a:p>
+        </p:txBody>
+      </p:sp>
+      <p:sp>
+        <p:nvSpPr>
+          <p:cNvPr id="10" name="Oval 9"/>
+          <p:cNvSpPr/>
+          <p:nvPr/>
+        </p:nvSpPr>
+        <p:spPr>
+          <a:xfrm>
+            <a:off x="8275320" y="1965960"/>
+            <a:ext cx="1097280" cy="1097280"/>
+          </a:xfrm>
+          <a:prstGeom prst="ellipse">
+            <a:avLst/>
+          </a:prstGeom>
+          <a:solidFill>
+            <a:srgbClr val="F7E1D5"/>
+          </a:solidFill>
+          <a:ln>
+            <a:noFill/>
+          </a:ln>
+          <a:effectLst/>
+        </p:spPr>
+        <p:style>
+          <a:lnRef idx="1">
+            <a:schemeClr val="accent1"/>
+          </a:lnRef>
+          <a:fillRef idx="3">
+            <a:schemeClr val="accent1"/>
+          </a:fillRef>
+          <a:effectRef idx="2">
+            <a:schemeClr val="accent1"/>
+          </a:effectRef>
+          <a:fontRef idx="minor">
+            <a:schemeClr val="lt1"/>
+          </a:fontRef>
+        </p:style>
+        <p:txBody>
+          <a:bodyPr rtlCol="0" anchor="ctr" lIns="0" rIns="0" tIns="0" bIns="0" wrap="none"/>
+          <a:lstStyle/>
+          <a:p>
+            <a:pPr algn="ctr"/>
+            <a:r>
+              <a:rPr sz="3300">
+                <a:solidFill>
+                  <a:srgbClr val="DD6B42"/>
+                </a:solidFill>
+              </a:rPr>
+              <a:t>🍎</a:t>
+            </a:r>
+          </a:p>
+        </p:txBody>
+      </p:sp>
+      <p:sp>
+        <p:nvSpPr>
+          <p:cNvPr id="11" name="TextBox 10"/>
+          <p:cNvSpPr txBox="1"/>
+          <p:nvPr/>
+        </p:nvSpPr>
+        <p:spPr>
+          <a:xfrm>
+            <a:off x="8001000" y="3154680"/>
+            <a:ext cx="1645920" cy="365760"/>
+          </a:xfrm>
+          <a:prstGeom prst="rect">
+            <a:avLst/>
+          </a:prstGeom>
+          <a:noFill/>
+        </p:spPr>
+        <p:txBody>
+          <a:bodyPr wrap="square" anchor="t" lIns="0" rIns="0" tIns="0" bIns="0">
+            <a:spAutoFit/>
+          </a:bodyPr>
+          <a:lstStyle/>
+          <a:p>
+            <a:pPr algn="ctr">
+              <a:lnSpc>
+                <a:spcPct val="115000"/>
+              </a:lnSpc>
+            </a:pPr>
+            <a:r>
+              <a:rPr sz="1400" b="1" i="0">
+                <a:solidFill>
+                  <a:srgbClr val="1F2D22"/>
+                </a:solidFill>
+                <a:latin typeface="Calibri"/>
+              </a:rPr>
+              <a:t>Fruit</a:t>
+            </a:r>
+          </a:p>
+        </p:txBody>
+      </p:sp>
+      <p:sp>
+        <p:nvSpPr>
+          <p:cNvPr id="12" name="Rounded Rectangle 11"/>
+          <p:cNvSpPr/>
+          <p:nvPr/>
+        </p:nvSpPr>
+        <p:spPr>
+          <a:xfrm>
+            <a:off x="914400" y="3886200"/>
+            <a:ext cx="1554480" cy="594360"/>
+          </a:xfrm>
+          <a:prstGeom prst="roundRect">
+            <a:avLst>
+              <a:gd name="adj" fmla="val 10000"/>
+            </a:avLst>
+          </a:prstGeom>
+          <a:solidFill>
+            <a:srgbClr val="DCE8D9"/>
+          </a:solidFill>
+          <a:ln>
+            <a:noFill/>
+          </a:ln>
+          <a:effectLst/>
+        </p:spPr>
+        <p:style>
+          <a:lnRef idx="1">
+            <a:schemeClr val="accent1"/>
+          </a:lnRef>
+          <a:fillRef idx="3">
+            <a:schemeClr val="accent1"/>
+          </a:fillRef>
+          <a:effectRef idx="2">
+            <a:schemeClr val="accent1"/>
+          </a:effectRef>
+          <a:fontRef idx="minor">
+            <a:schemeClr val="lt1"/>
+          </a:fontRef>
+        </p:style>
+        <p:txBody>
+          <a:bodyPr rtlCol="0" anchor="ctr"/>
+          <a:lstStyle/>
+          <a:p>
+            <a:pPr algn="ctr"/>
+          </a:p>
+        </p:txBody>
+      </p:sp>
+      <p:sp>
+        <p:nvSpPr>
+          <p:cNvPr id="13" name="TextBox 12"/>
+          <p:cNvSpPr txBox="1"/>
+          <p:nvPr/>
+        </p:nvSpPr>
+        <p:spPr>
+          <a:xfrm>
+            <a:off x="914400" y="3886200"/>
+            <a:ext cx="1554480" cy="594360"/>
+          </a:xfrm>
+          <a:prstGeom prst="rect">
+            <a:avLst/>
+          </a:prstGeom>
+          <a:noFill/>
+        </p:spPr>
+        <p:txBody>
+          <a:bodyPr wrap="square" anchor="ctr" lIns="0" rIns="0" tIns="0" bIns="0">
+            <a:spAutoFit/>
+          </a:bodyPr>
+          <a:lstStyle/>
+          <a:p>
+            <a:pPr algn="ctr">
+              <a:lnSpc>
+                <a:spcPct val="115000"/>
+              </a:lnSpc>
+            </a:pPr>
+            <a:r>
+              <a:rPr sz="1300" b="1" i="0">
+                <a:solidFill>
+                  <a:srgbClr val="2C5A44"/>
+                </a:solidFill>
+                <a:latin typeface="Calibri"/>
+              </a:rPr>
+              <a:t>Checklist</a:t>
+            </a:r>
+          </a:p>
+        </p:txBody>
+      </p:sp>
+      <p:sp>
+        <p:nvSpPr>
+          <p:cNvPr id="14" name="TextBox 13"/>
+          <p:cNvSpPr txBox="1"/>
+          <p:nvPr/>
+        </p:nvSpPr>
+        <p:spPr>
+          <a:xfrm>
+            <a:off x="2468880" y="3977639"/>
+            <a:ext cx="457200" cy="457200"/>
+          </a:xfrm>
+          <a:prstGeom prst="rect">
+            <a:avLst/>
+          </a:prstGeom>
+          <a:noFill/>
+        </p:spPr>
+        <p:txBody>
+          <a:bodyPr wrap="square" anchor="t" lIns="0" rIns="0" tIns="0" bIns="0">
+            <a:spAutoFit/>
+          </a:bodyPr>
+          <a:lstStyle/>
+          <a:p>
+            <a:pPr algn="ctr">
+              <a:lnSpc>
+                <a:spcPct val="115000"/>
+              </a:lnSpc>
+            </a:pPr>
+            <a:r>
+              <a:rPr sz="2000" b="1" i="0">
+                <a:solidFill>
+                  <a:srgbClr val="DD6B42"/>
+                </a:solidFill>
+                <a:latin typeface="Calibri"/>
+              </a:rPr>
+              <a:t>→</a:t>
+            </a:r>
+          </a:p>
+        </p:txBody>
+      </p:sp>
+      <p:sp>
+        <p:nvSpPr>
+          <p:cNvPr id="15" name="Rounded Rectangle 14"/>
+          <p:cNvSpPr/>
+          <p:nvPr/>
+        </p:nvSpPr>
+        <p:spPr>
+          <a:xfrm>
+            <a:off x="2926080" y="3886200"/>
+            <a:ext cx="2286000" cy="594360"/>
+          </a:xfrm>
+          <a:prstGeom prst="roundRect">
+            <a:avLst>
+              <a:gd name="adj" fmla="val 10000"/>
+            </a:avLst>
+          </a:prstGeom>
+          <a:solidFill>
+            <a:srgbClr val="DCE8D9"/>
+          </a:solidFill>
+          <a:ln>
+            <a:noFill/>
+          </a:ln>
+          <a:effectLst/>
+        </p:spPr>
+        <p:style>
+          <a:lnRef idx="1">
+            <a:schemeClr val="accent1"/>
+          </a:lnRef>
+          <a:fillRef idx="3">
+            <a:schemeClr val="accent1"/>
+          </a:fillRef>
+          <a:effectRef idx="2">
+            <a:schemeClr val="accent1"/>
+          </a:effectRef>
+          <a:fontRef idx="minor">
+            <a:schemeClr val="lt1"/>
+          </a:fontRef>
+        </p:style>
+        <p:txBody>
+          <a:bodyPr rtlCol="0" anchor="ctr"/>
+          <a:lstStyle/>
+          <a:p>
+            <a:pPr algn="ctr"/>
+          </a:p>
+        </p:txBody>
+      </p:sp>
+      <p:sp>
+        <p:nvSpPr>
+          <p:cNvPr id="16" name="TextBox 15"/>
+          <p:cNvSpPr txBox="1"/>
+          <p:nvPr/>
+        </p:nvSpPr>
+        <p:spPr>
+          <a:xfrm>
+            <a:off x="2926080" y="3886200"/>
+            <a:ext cx="2286000" cy="594360"/>
+          </a:xfrm>
+          <a:prstGeom prst="rect">
+            <a:avLst/>
+          </a:prstGeom>
+          <a:noFill/>
+        </p:spPr>
+        <p:txBody>
+          <a:bodyPr wrap="square" anchor="ctr" lIns="0" rIns="0" tIns="0" bIns="0">
+            <a:spAutoFit/>
+          </a:bodyPr>
+          <a:lstStyle/>
+          <a:p>
+            <a:pPr algn="ctr">
+              <a:lnSpc>
+                <a:spcPct val="115000"/>
+              </a:lnSpc>
+            </a:pPr>
+            <a:r>
+              <a:rPr sz="1300" b="1" i="0">
+                <a:solidFill>
+                  <a:srgbClr val="2C5A44"/>
+                </a:solidFill>
+                <a:latin typeface="Calibri"/>
+              </a:rPr>
+              <a:t>Photo or PIN Proof</a:t>
+            </a:r>
+          </a:p>
+        </p:txBody>
+      </p:sp>
+      <p:sp>
+        <p:nvSpPr>
+          <p:cNvPr id="17" name="TextBox 16"/>
+          <p:cNvSpPr txBox="1"/>
+          <p:nvPr/>
+        </p:nvSpPr>
+        <p:spPr>
+          <a:xfrm>
+            <a:off x="5212080" y="3977639"/>
+            <a:ext cx="457200" cy="457200"/>
+          </a:xfrm>
+          <a:prstGeom prst="rect">
+            <a:avLst/>
+          </a:prstGeom>
+          <a:noFill/>
+        </p:spPr>
+        <p:txBody>
+          <a:bodyPr wrap="square" anchor="t" lIns="0" rIns="0" tIns="0" bIns="0">
+            <a:spAutoFit/>
+          </a:bodyPr>
+          <a:lstStyle/>
+          <a:p>
+            <a:pPr algn="ctr">
+              <a:lnSpc>
+                <a:spcPct val="115000"/>
+              </a:lnSpc>
+            </a:pPr>
+            <a:r>
+              <a:rPr sz="2000" b="1" i="0">
+                <a:solidFill>
+                  <a:srgbClr val="DD6B42"/>
+                </a:solidFill>
+                <a:latin typeface="Calibri"/>
+              </a:rPr>
+              <a:t>→</a:t>
+            </a:r>
+          </a:p>
+        </p:txBody>
+      </p:sp>
+      <p:sp>
+        <p:nvSpPr>
+          <p:cNvPr id="18" name="Rounded Rectangle 17"/>
+          <p:cNvSpPr/>
+          <p:nvPr/>
+        </p:nvSpPr>
+        <p:spPr>
+          <a:xfrm>
+            <a:off x="5669280" y="3886200"/>
+            <a:ext cx="2103120" cy="594360"/>
+          </a:xfrm>
+          <a:prstGeom prst="roundRect">
+            <a:avLst>
+              <a:gd name="adj" fmla="val 10000"/>
+            </a:avLst>
+          </a:prstGeom>
+          <a:solidFill>
+            <a:srgbClr val="DCE8D9"/>
+          </a:solidFill>
+          <a:ln>
+            <a:noFill/>
+          </a:ln>
+          <a:effectLst/>
+        </p:spPr>
+        <p:style>
+          <a:lnRef idx="1">
+            <a:schemeClr val="accent1"/>
+          </a:lnRef>
+          <a:fillRef idx="3">
+            <a:schemeClr val="accent1"/>
+          </a:fillRef>
+          <a:effectRef idx="2">
+            <a:schemeClr val="accent1"/>
+          </a:effectRef>
+          <a:fontRef idx="minor">
+            <a:schemeClr val="lt1"/>
+          </a:fontRef>
+        </p:style>
+        <p:txBody>
+          <a:bodyPr rtlCol="0" anchor="ctr"/>
+          <a:lstStyle/>
+          <a:p>
+            <a:pPr algn="ctr"/>
+          </a:p>
+        </p:txBody>
+      </p:sp>
+      <p:sp>
+        <p:nvSpPr>
+          <p:cNvPr id="19" name="TextBox 18"/>
+          <p:cNvSpPr txBox="1"/>
+          <p:nvPr/>
+        </p:nvSpPr>
+        <p:spPr>
+          <a:xfrm>
+            <a:off x="5669280" y="3886200"/>
+            <a:ext cx="2103120" cy="594360"/>
+          </a:xfrm>
+          <a:prstGeom prst="rect">
+            <a:avLst/>
+          </a:prstGeom>
+          <a:noFill/>
+        </p:spPr>
+        <p:txBody>
+          <a:bodyPr wrap="square" anchor="ctr" lIns="0" rIns="0" tIns="0" bIns="0">
+            <a:spAutoFit/>
+          </a:bodyPr>
+          <a:lstStyle/>
+          <a:p>
+            <a:pPr algn="ctr">
+              <a:lnSpc>
+                <a:spcPct val="115000"/>
+              </a:lnSpc>
+            </a:pPr>
+            <a:r>
+              <a:rPr sz="1300" b="1" i="0">
+                <a:solidFill>
+                  <a:srgbClr val="2C5A44"/>
+                </a:solidFill>
+                <a:latin typeface="Calibri"/>
+              </a:rPr>
+              <a:t>Minutes Banked</a:t>
+            </a:r>
+          </a:p>
+        </p:txBody>
+      </p:sp>
+      <p:sp>
+        <p:nvSpPr>
+          <p:cNvPr id="20" name="TextBox 19"/>
+          <p:cNvSpPr txBox="1"/>
+          <p:nvPr/>
+        </p:nvSpPr>
+        <p:spPr>
+          <a:xfrm>
+            <a:off x="7772400" y="3977639"/>
+            <a:ext cx="457200" cy="457200"/>
+          </a:xfrm>
+          <a:prstGeom prst="rect">
+            <a:avLst/>
+          </a:prstGeom>
+          <a:noFill/>
+        </p:spPr>
+        <p:txBody>
+          <a:bodyPr wrap="square" anchor="t" lIns="0" rIns="0" tIns="0" bIns="0">
+            <a:spAutoFit/>
+          </a:bodyPr>
+          <a:lstStyle/>
+          <a:p>
+            <a:pPr algn="ctr">
+              <a:lnSpc>
+                <a:spcPct val="115000"/>
+              </a:lnSpc>
+            </a:pPr>
+            <a:r>
+              <a:rPr sz="2000" b="1" i="0">
+                <a:solidFill>
+                  <a:srgbClr val="DD6B42"/>
+                </a:solidFill>
+                <a:latin typeface="Calibri"/>
+              </a:rPr>
+              <a:t>→</a:t>
+            </a:r>
+          </a:p>
+        </p:txBody>
+      </p:sp>
+      <p:sp>
+        <p:nvSpPr>
+          <p:cNvPr id="21" name="Rounded Rectangle 20"/>
+          <p:cNvSpPr/>
+          <p:nvPr/>
+        </p:nvSpPr>
+        <p:spPr>
+          <a:xfrm>
+            <a:off x="8229600" y="3886200"/>
+            <a:ext cx="1554480" cy="594360"/>
+          </a:xfrm>
+          <a:prstGeom prst="roundRect">
+            <a:avLst>
+              <a:gd name="adj" fmla="val 10000"/>
+            </a:avLst>
+          </a:prstGeom>
+          <a:solidFill>
+            <a:srgbClr val="DCE8D9"/>
+          </a:solidFill>
+          <a:ln>
+            <a:noFill/>
+          </a:ln>
+          <a:effectLst/>
+        </p:spPr>
+        <p:style>
+          <a:lnRef idx="1">
+            <a:schemeClr val="accent1"/>
+          </a:lnRef>
+          <a:fillRef idx="3">
+            <a:schemeClr val="accent1"/>
+          </a:fillRef>
+          <a:effectRef idx="2">
+            <a:schemeClr val="accent1"/>
+          </a:effectRef>
+          <a:fontRef idx="minor">
+            <a:schemeClr val="lt1"/>
+          </a:fontRef>
+        </p:style>
+        <p:txBody>
+          <a:bodyPr rtlCol="0" anchor="ctr"/>
+          <a:lstStyle/>
+          <a:p>
+            <a:pPr algn="ctr"/>
+          </a:p>
+        </p:txBody>
+      </p:sp>
+      <p:sp>
+        <p:nvSpPr>
+          <p:cNvPr id="22" name="TextBox 21"/>
+          <p:cNvSpPr txBox="1"/>
+          <p:nvPr/>
+        </p:nvSpPr>
+        <p:spPr>
+          <a:xfrm>
+            <a:off x="8229600" y="3886200"/>
+            <a:ext cx="1554480" cy="594360"/>
+          </a:xfrm>
+          <a:prstGeom prst="rect">
+            <a:avLst/>
+          </a:prstGeom>
+          <a:noFill/>
+        </p:spPr>
+        <p:txBody>
+          <a:bodyPr wrap="square" anchor="ctr" lIns="0" rIns="0" tIns="0" bIns="0">
+            <a:spAutoFit/>
+          </a:bodyPr>
+          <a:lstStyle/>
+          <a:p>
+            <a:pPr algn="ctr">
+              <a:lnSpc>
+                <a:spcPct val="115000"/>
+              </a:lnSpc>
+            </a:pPr>
+            <a:r>
+              <a:rPr sz="1300" b="1" i="0">
+                <a:solidFill>
+                  <a:srgbClr val="2C5A44"/>
+                </a:solidFill>
+                <a:latin typeface="Calibri"/>
+              </a:rPr>
+              <a:t>Unlock</a:t>
+            </a:r>
+          </a:p>
+        </p:txBody>
+      </p:sp>
+      <p:sp>
+        <p:nvSpPr>
+          <p:cNvPr id="23" name="Rounded Rectangle 22"/>
+          <p:cNvSpPr/>
+          <p:nvPr/>
+        </p:nvSpPr>
+        <p:spPr>
+          <a:xfrm>
+            <a:off x="822960" y="4846320"/>
+            <a:ext cx="10515600" cy="1371600"/>
+          </a:xfrm>
+          <a:prstGeom prst="roundRect">
+            <a:avLst>
+              <a:gd name="adj" fmla="val 10000"/>
+            </a:avLst>
+          </a:prstGeom>
+          <a:solidFill>
+            <a:srgbClr val="F5E7C9"/>
+          </a:solidFill>
+          <a:ln>
+            <a:noFill/>
+          </a:ln>
+          <a:effectLst/>
+        </p:spPr>
+        <p:style>
+          <a:lnRef idx="1">
+            <a:schemeClr val="accent1"/>
+          </a:lnRef>
+          <a:fillRef idx="3">
+            <a:schemeClr val="accent1"/>
+          </a:fillRef>
+          <a:effectRef idx="2">
+            <a:schemeClr val="accent1"/>
+          </a:effectRef>
+          <a:fontRef idx="minor">
+            <a:schemeClr val="lt1"/>
+          </a:fontRef>
+        </p:style>
+        <p:txBody>
+          <a:bodyPr rtlCol="0" anchor="ctr"/>
+          <a:lstStyle/>
+          <a:p>
+            <a:pPr algn="ctr"/>
+          </a:p>
+        </p:txBody>
+      </p:sp>
+      <p:sp>
+        <p:nvSpPr>
+          <p:cNvPr id="24" name="TextBox 23"/>
+          <p:cNvSpPr txBox="1"/>
+          <p:nvPr/>
+        </p:nvSpPr>
+        <p:spPr>
+          <a:xfrm>
+            <a:off x="1188720" y="5074920"/>
+            <a:ext cx="9784080" cy="914400"/>
+          </a:xfrm>
+          <a:prstGeom prst="rect">
+            <a:avLst/>
+          </a:prstGeom>
+          <a:noFill/>
+        </p:spPr>
+        <p:txBody>
+          <a:bodyPr wrap="square" anchor="ctr" lIns="0" rIns="0" tIns="0" bIns="0">
+            <a:spAutoFit/>
+          </a:bodyPr>
+          <a:lstStyle/>
+          <a:p>
+            <a:pPr algn="l">
+              <a:lnSpc>
+                <a:spcPct val="125000"/>
+              </a:lnSpc>
+            </a:pPr>
+            <a:r>
+              <a:rPr sz="1350" b="0" i="0">
+                <a:solidFill>
+                  <a:srgbClr val="2C5A44"/>
+                </a:solidFill>
+                <a:latin typeface="Calibri"/>
+              </a:rPr>
+              <a:t>The one exception: Sleep is checked each morning about last night's bedtime, not at night — a real bug we caught and fixed, so the reward is never gated on something unverifiable until after bedtime.</a:t>
+            </a:r>
+          </a:p>
+        </p:txBody>
+      </p:sp>
+    </p:spTree>
+  </p:cSld>
+  <p:clrMapOvr>
+    <a:masterClrMapping/>
+  </p:clrMapOvr>
+</p:sld>
+</file>
+
+<file path=ppt/slides/slide6.xml><?xml version="1.0" encoding="utf-8"?>
 <p:sld xmlns:a="http://schemas.openxmlformats.org/drawingml/2006/main" xmlns:p="http://schemas.openxmlformats.org/presentationml/2006/main" xmlns:r="http://schemas.openxmlformats.org/officeDocument/2006/relationships">
   <p:cSld>
     <p:bg>
@@ -6891,7 +8122,7 @@
 </p:sld>
 </file>
 
-<file path=ppt/slides/slide6.xml><?xml version="1.0" encoding="utf-8"?>
+<file path=ppt/slides/slide7.xml><?xml version="1.0" encoding="utf-8"?>
 <p:sld xmlns:a="http://schemas.openxmlformats.org/drawingml/2006/main" xmlns:p="http://schemas.openxmlformats.org/presentationml/2006/main" xmlns:r="http://schemas.openxmlformats.org/officeDocument/2006/relationships">
   <p:cSld>
     <p:bg>
@@ -7660,7 +8891,7 @@
 </p:sld>
 </file>
 
-<file path=ppt/slides/slide7.xml><?xml version="1.0" encoding="utf-8"?>
+<file path=ppt/slides/slide8.xml><?xml version="1.0" encoding="utf-8"?>
 <p:sld xmlns:a="http://schemas.openxmlformats.org/drawingml/2006/main" xmlns:p="http://schemas.openxmlformats.org/presentationml/2006/main" xmlns:r="http://schemas.openxmlformats.org/officeDocument/2006/relationships">
   <p:cSld>
     <p:bg>
@@ -8340,7 +9571,7 @@
 </p:sld>
 </file>
 
-<file path=ppt/slides/slide8.xml><?xml version="1.0" encoding="utf-8"?>
+<file path=ppt/slides/slide9.xml><?xml version="1.0" encoding="utf-8"?>
 <p:sld xmlns:a="http://schemas.openxmlformats.org/drawingml/2006/main" xmlns:p="http://schemas.openxmlformats.org/presentationml/2006/main" xmlns:r="http://schemas.openxmlformats.org/officeDocument/2006/relationships">
   <p:cSld>
     <p:bg>

</xml_diff>

<commit_message>
Update README, Week 6 doc, and pitch deck to describe the parent-review-queue + bulk-approve workflow
</commit_message>
<xml_diff>
--- a/Health_First_Week6_Pitch.pptx
+++ b/Health_First_Week6_Pitch.pptx
@@ -6895,8 +6895,8 @@
         </p:nvSpPr>
         <p:spPr>
           <a:xfrm>
-            <a:off x="914400" y="3886200"/>
-            <a:ext cx="1554480" cy="594360"/>
+            <a:off x="822960" y="3886200"/>
+            <a:ext cx="1371600" cy="594360"/>
           </a:xfrm>
           <a:prstGeom prst="roundRect">
             <a:avLst>
@@ -6941,8 +6941,8 @@
         </p:nvSpPr>
         <p:spPr>
           <a:xfrm>
-            <a:off x="914400" y="3886200"/>
-            <a:ext cx="1554480" cy="594360"/>
+            <a:off x="822960" y="3886200"/>
+            <a:ext cx="1371600" cy="594360"/>
           </a:xfrm>
           <a:prstGeom prst="rect">
             <a:avLst/>
@@ -6961,7 +6961,7 @@
               </a:lnSpc>
             </a:pPr>
             <a:r>
-              <a:rPr sz="1300" b="1" i="0">
+              <a:rPr sz="1200" b="1" i="0">
                 <a:solidFill>
                   <a:srgbClr val="2C5A44"/>
                 </a:solidFill>
@@ -6980,8 +6980,8 @@
         </p:nvSpPr>
         <p:spPr>
           <a:xfrm>
-            <a:off x="2468880" y="3977639"/>
-            <a:ext cx="457200" cy="457200"/>
+            <a:off x="2194560" y="3977639"/>
+            <a:ext cx="320040" cy="457200"/>
           </a:xfrm>
           <a:prstGeom prst="rect">
             <a:avLst/>
@@ -7000,7 +7000,7 @@
               </a:lnSpc>
             </a:pPr>
             <a:r>
-              <a:rPr sz="2000" b="1" i="0">
+              <a:rPr sz="1700" b="1" i="0">
                 <a:solidFill>
                   <a:srgbClr val="DD6B42"/>
                 </a:solidFill>
@@ -7019,8 +7019,8 @@
         </p:nvSpPr>
         <p:spPr>
           <a:xfrm>
-            <a:off x="2926080" y="3886200"/>
-            <a:ext cx="2286000" cy="594360"/>
+            <a:off x="2514600" y="3886200"/>
+            <a:ext cx="2148840" cy="594360"/>
           </a:xfrm>
           <a:prstGeom prst="roundRect">
             <a:avLst>
@@ -7065,8 +7065,8 @@
         </p:nvSpPr>
         <p:spPr>
           <a:xfrm>
-            <a:off x="2926080" y="3886200"/>
-            <a:ext cx="2286000" cy="594360"/>
+            <a:off x="2514600" y="3886200"/>
+            <a:ext cx="2148840" cy="594360"/>
           </a:xfrm>
           <a:prstGeom prst="rect">
             <a:avLst/>
@@ -7085,13 +7085,13 @@
               </a:lnSpc>
             </a:pPr>
             <a:r>
-              <a:rPr sz="1300" b="1" i="0">
+              <a:rPr sz="1200" b="1" i="0">
                 <a:solidFill>
                   <a:srgbClr val="2C5A44"/>
                 </a:solidFill>
                 <a:latin typeface="Calibri"/>
               </a:rPr>
-              <a:t>Photo or PIN Proof</a:t>
+              <a:t>Photo or Ask Parent</a:t>
             </a:r>
           </a:p>
         </p:txBody>
@@ -7104,8 +7104,8 @@
         </p:nvSpPr>
         <p:spPr>
           <a:xfrm>
-            <a:off x="5212080" y="3977639"/>
-            <a:ext cx="457200" cy="457200"/>
+            <a:off x="4663440" y="3977639"/>
+            <a:ext cx="320040" cy="457200"/>
           </a:xfrm>
           <a:prstGeom prst="rect">
             <a:avLst/>
@@ -7124,7 +7124,7 @@
               </a:lnSpc>
             </a:pPr>
             <a:r>
-              <a:rPr sz="2000" b="1" i="0">
+              <a:rPr sz="1700" b="1" i="0">
                 <a:solidFill>
                   <a:srgbClr val="DD6B42"/>
                 </a:solidFill>
@@ -7143,8 +7143,8 @@
         </p:nvSpPr>
         <p:spPr>
           <a:xfrm>
-            <a:off x="5669280" y="3886200"/>
-            <a:ext cx="2103120" cy="594360"/>
+            <a:off x="4983479" y="3886200"/>
+            <a:ext cx="1920240" cy="594360"/>
           </a:xfrm>
           <a:prstGeom prst="roundRect">
             <a:avLst>
@@ -7189,8 +7189,8 @@
         </p:nvSpPr>
         <p:spPr>
           <a:xfrm>
-            <a:off x="5669280" y="3886200"/>
-            <a:ext cx="2103120" cy="594360"/>
+            <a:off x="4983479" y="3886200"/>
+            <a:ext cx="1920240" cy="594360"/>
           </a:xfrm>
           <a:prstGeom prst="rect">
             <a:avLst/>
@@ -7209,13 +7209,13 @@
               </a:lnSpc>
             </a:pPr>
             <a:r>
-              <a:rPr sz="1300" b="1" i="0">
+              <a:rPr sz="1200" b="1" i="0">
                 <a:solidFill>
                   <a:srgbClr val="2C5A44"/>
                 </a:solidFill>
                 <a:latin typeface="Calibri"/>
               </a:rPr>
-              <a:t>Minutes Banked</a:t>
+              <a:t>Parent Approves</a:t>
             </a:r>
           </a:p>
         </p:txBody>
@@ -7228,8 +7228,8 @@
         </p:nvSpPr>
         <p:spPr>
           <a:xfrm>
-            <a:off x="7772400" y="3977639"/>
-            <a:ext cx="457200" cy="457200"/>
+            <a:off x="6903719" y="3977639"/>
+            <a:ext cx="320040" cy="457200"/>
           </a:xfrm>
           <a:prstGeom prst="rect">
             <a:avLst/>
@@ -7248,7 +7248,7 @@
               </a:lnSpc>
             </a:pPr>
             <a:r>
-              <a:rPr sz="2000" b="1" i="0">
+              <a:rPr sz="1700" b="1" i="0">
                 <a:solidFill>
                   <a:srgbClr val="DD6B42"/>
                 </a:solidFill>
@@ -7267,8 +7267,8 @@
         </p:nvSpPr>
         <p:spPr>
           <a:xfrm>
-            <a:off x="8229600" y="3886200"/>
-            <a:ext cx="1554480" cy="594360"/>
+            <a:off x="7223759" y="3886200"/>
+            <a:ext cx="1874519" cy="594360"/>
           </a:xfrm>
           <a:prstGeom prst="roundRect">
             <a:avLst>
@@ -7313,8 +7313,8 @@
         </p:nvSpPr>
         <p:spPr>
           <a:xfrm>
-            <a:off x="8229600" y="3886200"/>
-            <a:ext cx="1554480" cy="594360"/>
+            <a:off x="7223759" y="3886200"/>
+            <a:ext cx="1874519" cy="594360"/>
           </a:xfrm>
           <a:prstGeom prst="rect">
             <a:avLst/>
@@ -7333,12 +7333,136 @@
               </a:lnSpc>
             </a:pPr>
             <a:r>
-              <a:rPr sz="1300" b="1" i="0">
+              <a:rPr sz="1200" b="1" i="0">
                 <a:solidFill>
                   <a:srgbClr val="2C5A44"/>
                 </a:solidFill>
                 <a:latin typeface="Calibri"/>
               </a:rPr>
+              <a:t>Minutes Banked</a:t>
+            </a:r>
+          </a:p>
+        </p:txBody>
+      </p:sp>
+      <p:sp>
+        <p:nvSpPr>
+          <p:cNvPr id="23" name="TextBox 22"/>
+          <p:cNvSpPr txBox="1"/>
+          <p:nvPr/>
+        </p:nvSpPr>
+        <p:spPr>
+          <a:xfrm>
+            <a:off x="9098280" y="3977639"/>
+            <a:ext cx="320040" cy="457200"/>
+          </a:xfrm>
+          <a:prstGeom prst="rect">
+            <a:avLst/>
+          </a:prstGeom>
+          <a:noFill/>
+        </p:spPr>
+        <p:txBody>
+          <a:bodyPr wrap="square" anchor="t" lIns="0" rIns="0" tIns="0" bIns="0">
+            <a:spAutoFit/>
+          </a:bodyPr>
+          <a:lstStyle/>
+          <a:p>
+            <a:pPr algn="ctr">
+              <a:lnSpc>
+                <a:spcPct val="115000"/>
+              </a:lnSpc>
+            </a:pPr>
+            <a:r>
+              <a:rPr sz="1700" b="1" i="0">
+                <a:solidFill>
+                  <a:srgbClr val="DD6B42"/>
+                </a:solidFill>
+                <a:latin typeface="Calibri"/>
+              </a:rPr>
+              <a:t>→</a:t>
+            </a:r>
+          </a:p>
+        </p:txBody>
+      </p:sp>
+      <p:sp>
+        <p:nvSpPr>
+          <p:cNvPr id="24" name="Rounded Rectangle 23"/>
+          <p:cNvSpPr/>
+          <p:nvPr/>
+        </p:nvSpPr>
+        <p:spPr>
+          <a:xfrm>
+            <a:off x="9418319" y="3886200"/>
+            <a:ext cx="1280160" cy="594360"/>
+          </a:xfrm>
+          <a:prstGeom prst="roundRect">
+            <a:avLst>
+              <a:gd name="adj" fmla="val 10000"/>
+            </a:avLst>
+          </a:prstGeom>
+          <a:solidFill>
+            <a:srgbClr val="DCE8D9"/>
+          </a:solidFill>
+          <a:ln>
+            <a:noFill/>
+          </a:ln>
+          <a:effectLst/>
+        </p:spPr>
+        <p:style>
+          <a:lnRef idx="1">
+            <a:schemeClr val="accent1"/>
+          </a:lnRef>
+          <a:fillRef idx="3">
+            <a:schemeClr val="accent1"/>
+          </a:fillRef>
+          <a:effectRef idx="2">
+            <a:schemeClr val="accent1"/>
+          </a:effectRef>
+          <a:fontRef idx="minor">
+            <a:schemeClr val="lt1"/>
+          </a:fontRef>
+        </p:style>
+        <p:txBody>
+          <a:bodyPr rtlCol="0" anchor="ctr"/>
+          <a:lstStyle/>
+          <a:p>
+            <a:pPr algn="ctr"/>
+          </a:p>
+        </p:txBody>
+      </p:sp>
+      <p:sp>
+        <p:nvSpPr>
+          <p:cNvPr id="25" name="TextBox 24"/>
+          <p:cNvSpPr txBox="1"/>
+          <p:nvPr/>
+        </p:nvSpPr>
+        <p:spPr>
+          <a:xfrm>
+            <a:off x="9418319" y="3886200"/>
+            <a:ext cx="1280160" cy="594360"/>
+          </a:xfrm>
+          <a:prstGeom prst="rect">
+            <a:avLst/>
+          </a:prstGeom>
+          <a:noFill/>
+        </p:spPr>
+        <p:txBody>
+          <a:bodyPr wrap="square" anchor="ctr" lIns="0" rIns="0" tIns="0" bIns="0">
+            <a:spAutoFit/>
+          </a:bodyPr>
+          <a:lstStyle/>
+          <a:p>
+            <a:pPr algn="ctr">
+              <a:lnSpc>
+                <a:spcPct val="115000"/>
+              </a:lnSpc>
+            </a:pPr>
+            <a:r>
+              <a:rPr sz="1200" b="1" i="0">
+                <a:solidFill>
+                  <a:srgbClr val="2C5A44"/>
+                </a:solidFill>
+                <a:latin typeface="Calibri"/>
+              </a:rPr>
               <a:t>Unlock</a:t>
             </a:r>
           </a:p>
@@ -7346,7 +7470,7 @@
       </p:sp>
       <p:sp>
         <p:nvSpPr>
-          <p:cNvPr id="23" name="Rounded Rectangle 22"/>
+          <p:cNvPr id="26" name="Rounded Rectangle 25"/>
           <p:cNvSpPr/>
           <p:nvPr/>
         </p:nvSpPr>
@@ -7392,7 +7516,7 @@
       </p:sp>
       <p:sp>
         <p:nvSpPr>
-          <p:cNvPr id="24" name="TextBox 23"/>
+          <p:cNvPr id="27" name="TextBox 26"/>
           <p:cNvSpPr txBox="1"/>
           <p:nvPr/>
         </p:nvSpPr>
@@ -9099,7 +9223,7 @@
                 <a:spcPct val="115000"/>
               </a:lnSpc>
               <a:spcAft>
-                <a:spcPts val="2000"/>
+                <a:spcPts val="1800"/>
               </a:spcAft>
               <a:buClr>
                 <a:srgbClr val="3E7A5C"/>
@@ -9114,7 +9238,7 @@
                 </a:solidFill>
                 <a:latin typeface="Calibri"/>
               </a:rPr>
-              <a:t>Real photo upload and parent-PIN verification</a:t>
+              <a:t>Real photo upload, routed to an actual parent review queue</a:t>
             </a:r>
           </a:p>
           <a:p>
@@ -9123,7 +9247,7 @@
                 <a:spcPct val="115000"/>
               </a:lnSpc>
               <a:spcAft>
-                <a:spcPts val="2000"/>
+                <a:spcPts val="1800"/>
               </a:spcAft>
               <a:buClr>
                 <a:srgbClr val="3E7A5C"/>
@@ -9138,7 +9262,7 @@
                 </a:solidFill>
                 <a:latin typeface="Calibri"/>
               </a:rPr>
-              <a:t>A live countdown that spends banked minutes and warns before time runs out</a:t>
+              <a:t>One-tap bulk approve — a parent clears every waiting goal with a single PIN entry</a:t>
             </a:r>
           </a:p>
           <a:p>
@@ -9147,7 +9271,7 @@
                 <a:spcPct val="115000"/>
               </a:lnSpc>
               <a:spcAft>
-                <a:spcPts val="2000"/>
+                <a:spcPts val="1800"/>
               </a:spcAft>
               <a:buClr>
                 <a:srgbClr val="3E7A5C"/>
@@ -9162,7 +9286,7 @@
                 </a:solidFill>
                 <a:latin typeface="Calibri"/>
               </a:rPr>
-              <a:t>State that persists day to day, with automatic daily reset</a:t>
+              <a:t>A live countdown that spends banked minutes and warns before time runs out</a:t>
             </a:r>
           </a:p>
           <a:p>
@@ -9171,7 +9295,7 @@
                 <a:spcPct val="115000"/>
               </a:lnSpc>
               <a:spcAft>
-                <a:spcPts val="2000"/>
+                <a:spcPts val="1800"/>
               </a:spcAft>
               <a:buClr>
                 <a:srgbClr val="3E7A5C"/>
@@ -9186,7 +9310,7 @@
                 </a:solidFill>
                 <a:latin typeface="Calibri"/>
               </a:rPr>
-              <a:t>A parent dashboard to add goals, set rewards, and approve proof</a:t>
+              <a:t>State that persists day to day, with automatic daily reset</a:t>
             </a:r>
           </a:p>
         </p:txBody>

</xml_diff>